<commit_message>
reso più chiaro l'analisi della stabilità del modello di competizione di Volterra
</commit_message>
<xml_diff>
--- a/Complex Systems/project/PresentationPROJECTSM3201466.pptx
+++ b/Complex Systems/project/PresentationPROJECTSM3201466.pptx
@@ -5,7 +5,7 @@
     <p:sldMasterId id="2147483648" r:id="rId1"/>
   </p:sldMasterIdLst>
   <p:notesMasterIdLst>
-    <p:notesMasterId r:id="rId33"/>
+    <p:notesMasterId r:id="rId31"/>
   </p:notesMasterIdLst>
   <p:sldIdLst>
     <p:sldId id="257" r:id="rId2"/>
@@ -31,14 +31,12 @@
     <p:sldId id="273" r:id="rId22"/>
     <p:sldId id="274" r:id="rId23"/>
     <p:sldId id="275" r:id="rId24"/>
-    <p:sldId id="276" r:id="rId25"/>
-    <p:sldId id="277" r:id="rId26"/>
-    <p:sldId id="278" r:id="rId27"/>
-    <p:sldId id="279" r:id="rId28"/>
-    <p:sldId id="286" r:id="rId29"/>
-    <p:sldId id="282" r:id="rId30"/>
-    <p:sldId id="284" r:id="rId31"/>
-    <p:sldId id="285" r:id="rId32"/>
+    <p:sldId id="278" r:id="rId25"/>
+    <p:sldId id="279" r:id="rId26"/>
+    <p:sldId id="286" r:id="rId27"/>
+    <p:sldId id="282" r:id="rId28"/>
+    <p:sldId id="284" r:id="rId29"/>
+    <p:sldId id="285" r:id="rId30"/>
   </p:sldIdLst>
   <p:sldSz cx="12192000" cy="6858000"/>
   <p:notesSz cx="6858000" cy="9144000"/>
@@ -227,7 +225,7 @@
           <a:p>
             <a:fld id="{BEA086CB-A695-49D9-8C2E-9873859BCA4A}" type="datetimeFigureOut">
               <a:rPr lang="en-US" smtClean="0"/>
-              <a:t>1/3/2026</a:t>
+              <a:t>1/4/2026</a:t>
             </a:fld>
             <a:endParaRPr lang="en-US"/>
           </a:p>
@@ -641,7 +639,7 @@
           <a:p>
             <a:fld id="{F07E9E74-BB92-43A1-93A9-56899A08A8EA}" type="datetime1">
               <a:rPr lang="it-IT" smtClean="0"/>
-              <a:t>03/01/2026</a:t>
+              <a:t>04/01/2026</a:t>
             </a:fld>
             <a:endParaRPr lang="en-US"/>
           </a:p>
@@ -843,7 +841,7 @@
           <a:p>
             <a:fld id="{52F8FB06-37EE-426F-B4C2-4056D956FFB6}" type="datetime1">
               <a:rPr lang="it-IT" smtClean="0"/>
-              <a:t>03/01/2026</a:t>
+              <a:t>04/01/2026</a:t>
             </a:fld>
             <a:endParaRPr lang="en-US"/>
           </a:p>
@@ -1055,7 +1053,7 @@
           <a:p>
             <a:fld id="{60D66374-9FAD-424A-A417-2FC77F42A162}" type="datetime1">
               <a:rPr lang="it-IT" smtClean="0"/>
-              <a:t>03/01/2026</a:t>
+              <a:t>04/01/2026</a:t>
             </a:fld>
             <a:endParaRPr lang="en-US"/>
           </a:p>
@@ -1257,7 +1255,7 @@
           <a:p>
             <a:fld id="{98FE7E5C-3220-4614-A522-AFD916A4C527}" type="datetime1">
               <a:rPr lang="it-IT" smtClean="0"/>
-              <a:t>03/01/2026</a:t>
+              <a:t>04/01/2026</a:t>
             </a:fld>
             <a:endParaRPr lang="en-US"/>
           </a:p>
@@ -1536,7 +1534,7 @@
           <a:p>
             <a:fld id="{67EDB044-EFFF-4CBD-97F7-2F91E5899AD1}" type="datetime1">
               <a:rPr lang="it-IT" smtClean="0"/>
-              <a:t>03/01/2026</a:t>
+              <a:t>04/01/2026</a:t>
             </a:fld>
             <a:endParaRPr lang="en-US"/>
           </a:p>
@@ -1805,7 +1803,7 @@
           <a:p>
             <a:fld id="{CE358A1C-7692-454B-B2B0-19CF8E1B29B2}" type="datetime1">
               <a:rPr lang="it-IT" smtClean="0"/>
-              <a:t>03/01/2026</a:t>
+              <a:t>04/01/2026</a:t>
             </a:fld>
             <a:endParaRPr lang="en-US"/>
           </a:p>
@@ -2221,7 +2219,7 @@
           <a:p>
             <a:fld id="{EA334287-8B58-4D94-B233-149ADA4285AB}" type="datetime1">
               <a:rPr lang="it-IT" smtClean="0"/>
-              <a:t>03/01/2026</a:t>
+              <a:t>04/01/2026</a:t>
             </a:fld>
             <a:endParaRPr lang="en-US"/>
           </a:p>
@@ -2366,7 +2364,7 @@
           <a:p>
             <a:fld id="{13469EFB-7A72-40B7-8B4E-23EC3F3D9178}" type="datetime1">
               <a:rPr lang="it-IT" smtClean="0"/>
-              <a:t>03/01/2026</a:t>
+              <a:t>04/01/2026</a:t>
             </a:fld>
             <a:endParaRPr lang="en-US"/>
           </a:p>
@@ -2483,7 +2481,7 @@
           <a:p>
             <a:fld id="{BC1B6C92-C1CD-4F55-ADFF-59EB1DF3CE0B}" type="datetime1">
               <a:rPr lang="it-IT" smtClean="0"/>
-              <a:t>03/01/2026</a:t>
+              <a:t>04/01/2026</a:t>
             </a:fld>
             <a:endParaRPr lang="en-US"/>
           </a:p>
@@ -2798,7 +2796,7 @@
           <a:p>
             <a:fld id="{5B54A038-0D44-4453-9D70-4F5E44A505EF}" type="datetime1">
               <a:rPr lang="it-IT" smtClean="0"/>
-              <a:t>03/01/2026</a:t>
+              <a:t>04/01/2026</a:t>
             </a:fld>
             <a:endParaRPr lang="en-US"/>
           </a:p>
@@ -3090,7 +3088,7 @@
           <a:p>
             <a:fld id="{F21DD4DD-220B-420A-80A9-E353ADB19088}" type="datetime1">
               <a:rPr lang="it-IT" smtClean="0"/>
-              <a:t>03/01/2026</a:t>
+              <a:t>04/01/2026</a:t>
             </a:fld>
             <a:endParaRPr lang="en-US"/>
           </a:p>
@@ -3335,7 +3333,7 @@
           <a:p>
             <a:fld id="{28ACF47F-4A45-43A2-A4A7-840A2C11A772}" type="datetime1">
               <a:rPr lang="it-IT" smtClean="0"/>
-              <a:t>03/01/2026</a:t>
+              <a:t>04/01/2026</a:t>
             </a:fld>
             <a:endParaRPr lang="en-US" dirty="0"/>
           </a:p>
@@ -3918,7 +3916,7 @@
           <a:p>
             <a:fld id="{52B8E00E-772D-4437-B382-3CBA9B54C360}" type="datetime1">
               <a:rPr lang="it-IT" smtClean="0"/>
-              <a:t>03/01/2026</a:t>
+              <a:t>04/01/2026</a:t>
             </a:fld>
             <a:endParaRPr lang="en-US"/>
           </a:p>
@@ -4354,7 +4352,7 @@
           <a:p>
             <a:fld id="{EA77D956-8483-48F0-B072-75AF7025ADAB}" type="datetime1">
               <a:rPr lang="it-IT" smtClean="0"/>
-              <a:t>03/01/2026</a:t>
+              <a:t>04/01/2026</a:t>
             </a:fld>
             <a:endParaRPr lang="en-US"/>
           </a:p>
@@ -4630,7 +4628,7 @@
           <a:p>
             <a:fld id="{7B4D458A-1DE7-4BA5-AF5A-3746645FA5DB}" type="datetime1">
               <a:rPr lang="it-IT" smtClean="0"/>
-              <a:t>03/01/2026</a:t>
+              <a:t>04/01/2026</a:t>
             </a:fld>
             <a:endParaRPr lang="en-US"/>
           </a:p>
@@ -4948,7 +4946,7 @@
           <a:p>
             <a:fld id="{0F073BDE-955B-4E08-A876-9008EBC2E5D9}" type="datetime1">
               <a:rPr lang="it-IT" smtClean="0"/>
-              <a:t>03/01/2026</a:t>
+              <a:t>04/01/2026</a:t>
             </a:fld>
             <a:endParaRPr lang="en-US"/>
           </a:p>
@@ -5266,7 +5264,7 @@
           <a:p>
             <a:fld id="{85077CAD-8672-4530-9999-911CF4F320CA}" type="datetime1">
               <a:rPr lang="it-IT" smtClean="0"/>
-              <a:t>03/01/2026</a:t>
+              <a:t>04/01/2026</a:t>
             </a:fld>
             <a:endParaRPr lang="en-US"/>
           </a:p>
@@ -5675,7 +5673,7 @@
           <a:p>
             <a:fld id="{A2AF2A43-5120-4B7D-95A3-344374AC366D}" type="datetime1">
               <a:rPr lang="it-IT" smtClean="0"/>
-              <a:t>03/01/2026</a:t>
+              <a:t>04/01/2026</a:t>
             </a:fld>
             <a:endParaRPr lang="en-US"/>
           </a:p>
@@ -5999,7 +5997,7 @@
           <a:p>
             <a:fld id="{0E4BD75C-8A8B-4E75-8D28-95927EC03BF3}" type="datetime1">
               <a:rPr lang="it-IT" smtClean="0"/>
-              <a:t>03/01/2026</a:t>
+              <a:t>04/01/2026</a:t>
             </a:fld>
             <a:endParaRPr lang="en-US"/>
           </a:p>
@@ -6391,7 +6389,7 @@
           <a:p>
             <a:fld id="{0E4BD75C-8A8B-4E75-8D28-95927EC03BF3}" type="datetime1">
               <a:rPr lang="it-IT" smtClean="0"/>
-              <a:t>03/01/2026</a:t>
+              <a:t>04/01/2026</a:t>
             </a:fld>
             <a:endParaRPr lang="en-US"/>
           </a:p>
@@ -6713,8 +6711,8 @@
           </a:p>
         </p:txBody>
       </p:sp>
-      <mc:AlternateContent xmlns:mc="http://schemas.openxmlformats.org/markup-compatibility/2006">
-        <mc:Choice xmlns:a14="http://schemas.microsoft.com/office/drawing/2010/main" Requires="a14">
+      <mc:AlternateContent xmlns:mc="http://schemas.openxmlformats.org/markup-compatibility/2006" xmlns:a14="http://schemas.microsoft.com/office/drawing/2010/main">
+        <mc:Choice Requires="a14">
           <p:sp>
             <p:nvSpPr>
               <p:cNvPr id="7" name="TextBox 6">
@@ -6924,7 +6922,7 @@
             </p:txBody>
           </p:sp>
         </mc:Choice>
-        <mc:Fallback>
+        <mc:Fallback xmlns="">
           <p:sp>
             <p:nvSpPr>
               <p:cNvPr id="7" name="TextBox 6">
@@ -7028,7 +7026,7 @@
           <a:p>
             <a:fld id="{0E4BD75C-8A8B-4E75-8D28-95927EC03BF3}" type="datetime1">
               <a:rPr lang="it-IT" smtClean="0"/>
-              <a:t>03/01/2026</a:t>
+              <a:t>04/01/2026</a:t>
             </a:fld>
             <a:endParaRPr lang="en-US"/>
           </a:p>
@@ -7395,7 +7393,7 @@
           <a:p>
             <a:fld id="{0E4BD75C-8A8B-4E75-8D28-95927EC03BF3}" type="datetime1">
               <a:rPr lang="it-IT" smtClean="0"/>
-              <a:t>03/01/2026</a:t>
+              <a:t>04/01/2026</a:t>
             </a:fld>
             <a:endParaRPr lang="en-US"/>
           </a:p>
@@ -7877,7 +7875,7 @@
           <a:p>
             <a:fld id="{22D2901C-25D2-4418-A5A0-267BB4E58730}" type="datetime1">
               <a:rPr lang="it-IT" smtClean="0"/>
-              <a:t>03/01/2026</a:t>
+              <a:t>04/01/2026</a:t>
             </a:fld>
             <a:endParaRPr lang="en-US"/>
           </a:p>
@@ -8358,7 +8356,7 @@
           <a:p>
             <a:fld id="{B4609506-6624-4C93-99FC-2FCD7C3B5EE8}" type="datetime1">
               <a:rPr lang="it-IT" smtClean="0"/>
-              <a:t>03/01/2026</a:t>
+              <a:t>04/01/2026</a:t>
             </a:fld>
             <a:endParaRPr lang="en-US"/>
           </a:p>
@@ -8791,7 +8789,7 @@
           <a:p>
             <a:fld id="{F2A62A29-0D40-4C95-BBC3-4CE9585C45D0}" type="datetime1">
               <a:rPr lang="it-IT" smtClean="0"/>
-              <a:t>03/01/2026</a:t>
+              <a:t>04/01/2026</a:t>
             </a:fld>
             <a:endParaRPr lang="en-US"/>
           </a:p>
@@ -9145,7 +9143,7 @@
           <a:p>
             <a:fld id="{E6091BEE-CBDC-4E52-BEE4-6FA4559C220C}" type="datetime1">
               <a:rPr lang="it-IT" smtClean="0"/>
-              <a:t>03/01/2026</a:t>
+              <a:t>04/01/2026</a:t>
             </a:fld>
             <a:endParaRPr lang="en-US"/>
           </a:p>
@@ -9575,7 +9573,7 @@
           <a:p>
             <a:fld id="{163A915D-2BA8-4F27-943A-17EA02CCA069}" type="datetime1">
               <a:rPr lang="it-IT" smtClean="0"/>
-              <a:t>03/01/2026</a:t>
+              <a:t>04/01/2026</a:t>
             </a:fld>
             <a:endParaRPr lang="en-US"/>
           </a:p>
@@ -9899,7 +9897,7 @@
           <a:p>
             <a:fld id="{536AB137-0A56-4868-923D-646D7C7CC445}" type="datetime1">
               <a:rPr lang="it-IT" smtClean="0"/>
-              <a:t>03/01/2026</a:t>
+              <a:t>04/01/2026</a:t>
             </a:fld>
             <a:endParaRPr lang="en-US"/>
           </a:p>
@@ -9984,7 +9982,7 @@
         <p:cNvPr id="1" name="">
           <a:extLst>
             <a:ext uri="{FF2B5EF4-FFF2-40B4-BE49-F238E27FC236}">
-              <a16:creationId xmlns:a16="http://schemas.microsoft.com/office/drawing/2014/main" id="{74B77452-60A4-53B8-652D-008E4EA9FB53}"/>
+              <a16:creationId xmlns:a16="http://schemas.microsoft.com/office/drawing/2014/main" id="{729FE9A4-6EA0-3AB3-6F89-BE1990D2F7BA}"/>
             </a:ext>
           </a:extLst>
         </p:cNvPr>
@@ -10004,7 +10002,7 @@
           <p:cNvPr id="3" name="TextBox 2">
             <a:extLst>
               <a:ext uri="{FF2B5EF4-FFF2-40B4-BE49-F238E27FC236}">
-                <a16:creationId xmlns:a16="http://schemas.microsoft.com/office/drawing/2014/main" id="{E99C2578-8874-C74D-3E16-6FF3FE3DA224}"/>
+                <a16:creationId xmlns:a16="http://schemas.microsoft.com/office/drawing/2014/main" id="{97B0DD3E-4157-B76F-9987-D1CD9DC5873B}"/>
               </a:ext>
             </a:extLst>
           </p:cNvPr>
@@ -10039,7 +10037,7 @@
           <p:cNvPr id="4" name="Rectangle 3">
             <a:extLst>
               <a:ext uri="{FF2B5EF4-FFF2-40B4-BE49-F238E27FC236}">
-                <a16:creationId xmlns:a16="http://schemas.microsoft.com/office/drawing/2014/main" id="{B377C2D9-F7F5-E652-0366-A39F3F7302A3}"/>
+                <a16:creationId xmlns:a16="http://schemas.microsoft.com/office/drawing/2014/main" id="{5CF43595-52D0-D7A0-717D-FDCAAB81CCE5}"/>
               </a:ext>
             </a:extLst>
           </p:cNvPr>
@@ -10088,137 +10086,10 @@
       </p:sp>
       <p:sp>
         <p:nvSpPr>
-          <p:cNvPr id="7" name="TextBox 6">
-            <a:extLst>
-              <a:ext uri="{FF2B5EF4-FFF2-40B4-BE49-F238E27FC236}">
-                <a16:creationId xmlns:a16="http://schemas.microsoft.com/office/drawing/2014/main" id="{DCDC62C6-31C1-2703-CF00-528C89686729}"/>
-              </a:ext>
-            </a:extLst>
-          </p:cNvPr>
-          <p:cNvSpPr txBox="1"/>
-          <p:nvPr/>
-        </p:nvSpPr>
-        <p:spPr>
-          <a:xfrm>
-            <a:off x="688257" y="1257642"/>
-            <a:ext cx="10028904" cy="3416320"/>
-          </a:xfrm>
-          <a:prstGeom prst="rect">
-            <a:avLst/>
-          </a:prstGeom>
-          <a:noFill/>
-        </p:spPr>
-        <p:txBody>
-          <a:bodyPr wrap="square" rtlCol="0">
-            <a:spAutoFit/>
-          </a:bodyPr>
-          <a:lstStyle/>
-          <a:p>
-            <a:pPr marL="285750" indent="-285750">
-              <a:buFont typeface="Wingdings" panose="05000000000000000000" pitchFamily="2" charset="2"/>
-              <a:buChar char="q"/>
-            </a:pPr>
-            <a:r>
-              <a:rPr lang="it-IT" sz="2400" dirty="0">
-                <a:latin typeface="Arial" panose="020B0604020202020204" pitchFamily="34" charset="0"/>
-                <a:cs typeface="Arial" panose="020B0604020202020204" pitchFamily="34" charset="0"/>
-              </a:rPr>
-              <a:t>Test della stabilità con la Jacobiana: W2 rimane «NOT LAS» con i parametri del primo esperimento</a:t>
-            </a:r>
-          </a:p>
-          <a:p>
-            <a:pPr marL="742950" lvl="1" indent="-285750">
-              <a:buFont typeface="Wingdings" panose="05000000000000000000" pitchFamily="2" charset="2"/>
-              <a:buChar char="q"/>
-            </a:pPr>
-            <a:r>
-              <a:rPr lang="it-IT" sz="2400" dirty="0">
-                <a:latin typeface="Arial" panose="020B0604020202020204" pitchFamily="34" charset="0"/>
-                <a:cs typeface="Arial" panose="020B0604020202020204" pitchFamily="34" charset="0"/>
-              </a:rPr>
-              <a:t>Il paper dichiarava che è LAS</a:t>
-            </a:r>
-          </a:p>
-          <a:p>
-            <a:pPr marL="742950" lvl="1" indent="-285750">
-              <a:buFont typeface="Wingdings" panose="05000000000000000000" pitchFamily="2" charset="2"/>
-              <a:buChar char="q"/>
-            </a:pPr>
-            <a:r>
-              <a:rPr lang="it-IT" sz="2400" dirty="0">
-                <a:latin typeface="Arial" panose="020B0604020202020204" pitchFamily="34" charset="0"/>
-                <a:cs typeface="Arial" panose="020B0604020202020204" pitchFamily="34" charset="0"/>
-              </a:rPr>
-              <a:t>Secondo la simulazione lo è «apparentemente»</a:t>
-            </a:r>
-          </a:p>
-          <a:p>
-            <a:pPr marL="285750" indent="-285750">
-              <a:buFont typeface="Wingdings" panose="05000000000000000000" pitchFamily="2" charset="2"/>
-              <a:buChar char="q"/>
-            </a:pPr>
-            <a:endParaRPr lang="it-IT" sz="2400" dirty="0">
-              <a:latin typeface="Arial" panose="020B0604020202020204" pitchFamily="34" charset="0"/>
-              <a:cs typeface="Arial" panose="020B0604020202020204" pitchFamily="34" charset="0"/>
-            </a:endParaRPr>
-          </a:p>
-          <a:p>
-            <a:pPr marL="285750" indent="-285750">
-              <a:buFont typeface="Wingdings" panose="05000000000000000000" pitchFamily="2" charset="2"/>
-              <a:buChar char="q"/>
-            </a:pPr>
-            <a:r>
-              <a:rPr lang="it-IT" sz="2400" dirty="0">
-                <a:latin typeface="Arial" panose="020B0604020202020204" pitchFamily="34" charset="0"/>
-                <a:cs typeface="Arial" panose="020B0604020202020204" pitchFamily="34" charset="0"/>
-              </a:rPr>
-              <a:t>Risultato inconsistente: rifatto l’esperimento</a:t>
-            </a:r>
-          </a:p>
-          <a:p>
-            <a:pPr marL="742950" lvl="1" indent="-285750">
-              <a:buFont typeface="Wingdings" panose="05000000000000000000" pitchFamily="2" charset="2"/>
-              <a:buChar char="q"/>
-            </a:pPr>
-            <a:r>
-              <a:rPr lang="it-IT" sz="2400" dirty="0">
-                <a:latin typeface="Arial" panose="020B0604020202020204" pitchFamily="34" charset="0"/>
-                <a:cs typeface="Arial" panose="020B0604020202020204" pitchFamily="34" charset="0"/>
-              </a:rPr>
-              <a:t>Prolungato la simulazione (T=600), </a:t>
-            </a:r>
-          </a:p>
-          <a:p>
-            <a:pPr marL="742950" lvl="1" indent="-285750">
-              <a:buFont typeface="Wingdings" panose="05000000000000000000" pitchFamily="2" charset="2"/>
-              <a:buChar char="q"/>
-            </a:pPr>
-            <a:r>
-              <a:rPr lang="it-IT" sz="2400" dirty="0">
-                <a:latin typeface="Arial" panose="020B0604020202020204" pitchFamily="34" charset="0"/>
-                <a:cs typeface="Arial" panose="020B0604020202020204" pitchFamily="34" charset="0"/>
-              </a:rPr>
-              <a:t>Zoom su W2 nel grafico (time series)</a:t>
-            </a:r>
-          </a:p>
-          <a:p>
-            <a:pPr marL="742950" lvl="1" indent="-285750">
-              <a:buFont typeface="Wingdings" panose="05000000000000000000" pitchFamily="2" charset="2"/>
-              <a:buChar char="q"/>
-            </a:pPr>
-            <a:endParaRPr lang="it-IT" sz="2400" dirty="0">
-              <a:latin typeface="Arial" panose="020B0604020202020204" pitchFamily="34" charset="0"/>
-              <a:cs typeface="Arial" panose="020B0604020202020204" pitchFamily="34" charset="0"/>
-            </a:endParaRPr>
-          </a:p>
-        </p:txBody>
-      </p:sp>
-      <p:sp>
-        <p:nvSpPr>
           <p:cNvPr id="9" name="TextBox 8">
             <a:extLst>
               <a:ext uri="{FF2B5EF4-FFF2-40B4-BE49-F238E27FC236}">
-                <a16:creationId xmlns:a16="http://schemas.microsoft.com/office/drawing/2014/main" id="{B59FD846-B850-2EE9-2713-55B4018AB9AE}"/>
+                <a16:creationId xmlns:a16="http://schemas.microsoft.com/office/drawing/2014/main" id="{BCA882A3-E78C-B2BA-6C34-867AB5F7AA15}"/>
               </a:ext>
             </a:extLst>
           </p:cNvPr>
@@ -10251,10 +10122,137 @@
       </p:sp>
       <p:sp>
         <p:nvSpPr>
-          <p:cNvPr id="2" name="Date Placeholder 1">
-            <a:extLst>
-              <a:ext uri="{FF2B5EF4-FFF2-40B4-BE49-F238E27FC236}">
-                <a16:creationId xmlns:a16="http://schemas.microsoft.com/office/drawing/2014/main" id="{51390EF2-A2B8-BBB5-966B-44A83DF61685}"/>
+          <p:cNvPr id="2" name="TextBox 1">
+            <a:extLst>
+              <a:ext uri="{FF2B5EF4-FFF2-40B4-BE49-F238E27FC236}">
+                <a16:creationId xmlns:a16="http://schemas.microsoft.com/office/drawing/2014/main" id="{5229A26A-3C47-D1AB-FDA1-B2AF227D8AB0}"/>
+              </a:ext>
+            </a:extLst>
+          </p:cNvPr>
+          <p:cNvSpPr txBox="1"/>
+          <p:nvPr/>
+        </p:nvSpPr>
+        <p:spPr>
+          <a:xfrm>
+            <a:off x="688257" y="1257642"/>
+            <a:ext cx="10028904" cy="3046988"/>
+          </a:xfrm>
+          <a:prstGeom prst="rect">
+            <a:avLst/>
+          </a:prstGeom>
+          <a:noFill/>
+        </p:spPr>
+        <p:txBody>
+          <a:bodyPr wrap="square" rtlCol="0">
+            <a:spAutoFit/>
+          </a:bodyPr>
+          <a:lstStyle/>
+          <a:p>
+            <a:pPr marL="285750" indent="-285750">
+              <a:buFont typeface="Wingdings" panose="05000000000000000000" pitchFamily="2" charset="2"/>
+              <a:buChar char="q"/>
+            </a:pPr>
+            <a:r>
+              <a:rPr lang="it-IT" sz="2400" dirty="0">
+                <a:latin typeface="Arial" panose="020B0604020202020204" pitchFamily="34" charset="0"/>
+                <a:cs typeface="Arial" panose="020B0604020202020204" pitchFamily="34" charset="0"/>
+              </a:rPr>
+              <a:t>Implicazioni</a:t>
+            </a:r>
+          </a:p>
+          <a:p>
+            <a:pPr marL="742950" lvl="1" indent="-285750">
+              <a:buFont typeface="Wingdings" panose="05000000000000000000" pitchFamily="2" charset="2"/>
+              <a:buChar char="q"/>
+            </a:pPr>
+            <a:r>
+              <a:rPr lang="it-IT" sz="2400" dirty="0">
+                <a:latin typeface="Arial" panose="020B0604020202020204" pitchFamily="34" charset="0"/>
+                <a:cs typeface="Arial" panose="020B0604020202020204" pitchFamily="34" charset="0"/>
+              </a:rPr>
+              <a:t>In realtà W2 non era mai LAS</a:t>
+            </a:r>
+          </a:p>
+          <a:p>
+            <a:pPr marL="1200150" lvl="2" indent="-285750">
+              <a:buFont typeface="Wingdings" panose="05000000000000000000" pitchFamily="2" charset="2"/>
+              <a:buChar char="q"/>
+            </a:pPr>
+            <a:r>
+              <a:rPr lang="it-IT" sz="2400" dirty="0">
+                <a:latin typeface="Arial" panose="020B0604020202020204" pitchFamily="34" charset="0"/>
+                <a:cs typeface="Arial" panose="020B0604020202020204" pitchFamily="34" charset="0"/>
+              </a:rPr>
+              <a:t>A discapito delle apparenze e quanto proposto nel paper</a:t>
+            </a:r>
+          </a:p>
+          <a:p>
+            <a:pPr marL="1200150" lvl="2" indent="-285750">
+              <a:buFont typeface="Wingdings" panose="05000000000000000000" pitchFamily="2" charset="2"/>
+              <a:buChar char="q"/>
+            </a:pPr>
+            <a:endParaRPr lang="it-IT" sz="2400" dirty="0">
+              <a:latin typeface="Arial" panose="020B0604020202020204" pitchFamily="34" charset="0"/>
+              <a:cs typeface="Arial" panose="020B0604020202020204" pitchFamily="34" charset="0"/>
+            </a:endParaRPr>
+          </a:p>
+          <a:p>
+            <a:pPr marL="285750" indent="-285750">
+              <a:buFont typeface="Wingdings" panose="05000000000000000000" pitchFamily="2" charset="2"/>
+              <a:buChar char="q"/>
+            </a:pPr>
+            <a:r>
+              <a:rPr lang="it-IT" sz="2400" dirty="0">
+                <a:latin typeface="Arial" panose="020B0604020202020204" pitchFamily="34" charset="0"/>
+                <a:cs typeface="Arial" panose="020B0604020202020204" pitchFamily="34" charset="0"/>
+              </a:rPr>
+              <a:t>Per confermare che non sia noise dovuto al risolutore:</a:t>
+            </a:r>
+          </a:p>
+          <a:p>
+            <a:pPr marL="742950" lvl="1" indent="-285750">
+              <a:buFont typeface="Wingdings" panose="05000000000000000000" pitchFamily="2" charset="2"/>
+              <a:buChar char="q"/>
+            </a:pPr>
+            <a:r>
+              <a:rPr lang="it-IT" sz="2400" dirty="0">
+                <a:latin typeface="Arial" panose="020B0604020202020204" pitchFamily="34" charset="0"/>
+                <a:cs typeface="Arial" panose="020B0604020202020204" pitchFamily="34" charset="0"/>
+              </a:rPr>
+              <a:t>Rieffettuato l’esperimento con metodi numerici diversi</a:t>
+            </a:r>
+          </a:p>
+          <a:p>
+            <a:pPr marL="742950" lvl="1" indent="-285750">
+              <a:buFont typeface="Wingdings" panose="05000000000000000000" pitchFamily="2" charset="2"/>
+              <a:buChar char="q"/>
+            </a:pPr>
+            <a:r>
+              <a:rPr lang="it-IT" sz="2400" dirty="0">
+                <a:latin typeface="Arial" panose="020B0604020202020204" pitchFamily="34" charset="0"/>
+                <a:cs typeface="Arial" panose="020B0604020202020204" pitchFamily="34" charset="0"/>
+              </a:rPr>
+              <a:t>Stessi risultati, confermato</a:t>
+            </a:r>
+          </a:p>
+          <a:p>
+            <a:pPr marL="742950" lvl="1" indent="-285750">
+              <a:buFont typeface="Wingdings" panose="05000000000000000000" pitchFamily="2" charset="2"/>
+              <a:buChar char="q"/>
+            </a:pPr>
+            <a:endParaRPr lang="it-IT" sz="2400" dirty="0">
+              <a:latin typeface="Arial" panose="020B0604020202020204" pitchFamily="34" charset="0"/>
+              <a:cs typeface="Arial" panose="020B0604020202020204" pitchFamily="34" charset="0"/>
+            </a:endParaRPr>
+          </a:p>
+        </p:txBody>
+      </p:sp>
+      <p:sp>
+        <p:nvSpPr>
+          <p:cNvPr id="5" name="Date Placeholder 4">
+            <a:extLst>
+              <a:ext uri="{FF2B5EF4-FFF2-40B4-BE49-F238E27FC236}">
+                <a16:creationId xmlns:a16="http://schemas.microsoft.com/office/drawing/2014/main" id="{2ED846B0-B38C-A692-E9A3-FFA97B60385E}"/>
               </a:ext>
             </a:extLst>
           </p:cNvPr>
@@ -10270,9 +10268,9 @@
           <a:bodyPr/>
           <a:lstStyle/>
           <a:p>
-            <a:fld id="{DCD21B3C-0FEB-4362-9619-5D2FABF53E43}" type="datetime1">
+            <a:fld id="{C5E77C2B-364A-4D71-8BAD-691E9BD64FFE}" type="datetime1">
               <a:rPr lang="it-IT" smtClean="0"/>
-              <a:t>03/01/2026</a:t>
+              <a:t>04/01/2026</a:t>
             </a:fld>
             <a:endParaRPr lang="en-US"/>
           </a:p>
@@ -10280,10 +10278,10 @@
       </p:sp>
       <p:sp>
         <p:nvSpPr>
-          <p:cNvPr id="5" name="Footer Placeholder 4">
-            <a:extLst>
-              <a:ext uri="{FF2B5EF4-FFF2-40B4-BE49-F238E27FC236}">
-                <a16:creationId xmlns:a16="http://schemas.microsoft.com/office/drawing/2014/main" id="{5521B956-4499-3184-8C33-996D0739C513}"/>
+          <p:cNvPr id="6" name="Footer Placeholder 5">
+            <a:extLst>
+              <a:ext uri="{FF2B5EF4-FFF2-40B4-BE49-F238E27FC236}">
+                <a16:creationId xmlns:a16="http://schemas.microsoft.com/office/drawing/2014/main" id="{F9469EB7-D049-4D97-ECD0-F3AE4915CDA4}"/>
               </a:ext>
             </a:extLst>
           </p:cNvPr>
@@ -10309,10 +10307,10 @@
       </p:sp>
       <p:sp>
         <p:nvSpPr>
-          <p:cNvPr id="6" name="Slide Number Placeholder 5">
-            <a:extLst>
-              <a:ext uri="{FF2B5EF4-FFF2-40B4-BE49-F238E27FC236}">
-                <a16:creationId xmlns:a16="http://schemas.microsoft.com/office/drawing/2014/main" id="{792BBE54-F7B0-EA44-F857-F163C5680F96}"/>
+          <p:cNvPr id="7" name="Slide Number Placeholder 6">
+            <a:extLst>
+              <a:ext uri="{FF2B5EF4-FFF2-40B4-BE49-F238E27FC236}">
+                <a16:creationId xmlns:a16="http://schemas.microsoft.com/office/drawing/2014/main" id="{2FF40AED-F76D-795E-5333-A4B81466833A}"/>
               </a:ext>
             </a:extLst>
           </p:cNvPr>
@@ -10339,7 +10337,7 @@
     </p:spTree>
     <p:extLst>
       <p:ext uri="{BB962C8B-B14F-4D97-AF65-F5344CB8AC3E}">
-        <p14:creationId xmlns:p14="http://schemas.microsoft.com/office/powerpoint/2010/main" val="678765483"/>
+        <p14:creationId xmlns:p14="http://schemas.microsoft.com/office/powerpoint/2010/main" val="393239306"/>
       </p:ext>
     </p:extLst>
   </p:cSld>
@@ -10357,7 +10355,7 @@
         <p:cNvPr id="1" name="">
           <a:extLst>
             <a:ext uri="{FF2B5EF4-FFF2-40B4-BE49-F238E27FC236}">
-              <a16:creationId xmlns:a16="http://schemas.microsoft.com/office/drawing/2014/main" id="{E082A180-B4A3-A9EB-9C6B-97B7E6484B17}"/>
+              <a16:creationId xmlns:a16="http://schemas.microsoft.com/office/drawing/2014/main" id="{DDC630C4-A2E7-4675-A543-9FEFEB48C66F}"/>
             </a:ext>
           </a:extLst>
         </p:cNvPr>
@@ -10377,7 +10375,7 @@
           <p:cNvPr id="3" name="TextBox 2">
             <a:extLst>
               <a:ext uri="{FF2B5EF4-FFF2-40B4-BE49-F238E27FC236}">
-                <a16:creationId xmlns:a16="http://schemas.microsoft.com/office/drawing/2014/main" id="{E5B1847E-2437-275D-BC8A-1158C45A42FE}"/>
+                <a16:creationId xmlns:a16="http://schemas.microsoft.com/office/drawing/2014/main" id="{AA900290-CEF3-1C84-ED74-6C905D2E8C39}"/>
               </a:ext>
             </a:extLst>
           </p:cNvPr>
@@ -10402,7 +10400,7 @@
           <a:p>
             <a:r>
               <a:rPr lang="it-IT" sz="2800" b="1" dirty="0"/>
-              <a:t>APPROFONDIMENTO SU W2</a:t>
+              <a:t>ULTERIORI SPERIMENTAZIONI </a:t>
             </a:r>
           </a:p>
         </p:txBody>
@@ -10412,7 +10410,7 @@
           <p:cNvPr id="4" name="Rectangle 3">
             <a:extLst>
               <a:ext uri="{FF2B5EF4-FFF2-40B4-BE49-F238E27FC236}">
-                <a16:creationId xmlns:a16="http://schemas.microsoft.com/office/drawing/2014/main" id="{64639D59-BF8C-D069-2A3D-938ED69BB493}"/>
+                <a16:creationId xmlns:a16="http://schemas.microsoft.com/office/drawing/2014/main" id="{A296E94F-3EDF-85B5-9FE9-C83560FAD80A}"/>
               </a:ext>
             </a:extLst>
           </p:cNvPr>
@@ -10464,7 +10462,7 @@
           <p:cNvPr id="9" name="TextBox 8">
             <a:extLst>
               <a:ext uri="{FF2B5EF4-FFF2-40B4-BE49-F238E27FC236}">
-                <a16:creationId xmlns:a16="http://schemas.microsoft.com/office/drawing/2014/main" id="{C8D9922D-1633-0551-E062-C52E3F0E267A}"/>
+                <a16:creationId xmlns:a16="http://schemas.microsoft.com/office/drawing/2014/main" id="{FE8E974E-5D79-EAAD-8215-1CA8EB2ACDE4}"/>
               </a:ext>
             </a:extLst>
           </p:cNvPr>
@@ -10490,655 +10488,6 @@
             <a:pPr algn="r"/>
             <a:r>
               <a:rPr lang="it-IT" sz="2400" b="1" i="1" dirty="0"/>
-              <a:t>Step: Confronto dei risultati</a:t>
-            </a:r>
-          </a:p>
-        </p:txBody>
-      </p:sp>
-      <p:sp>
-        <p:nvSpPr>
-          <p:cNvPr id="2" name="Date Placeholder 1">
-            <a:extLst>
-              <a:ext uri="{FF2B5EF4-FFF2-40B4-BE49-F238E27FC236}">
-                <a16:creationId xmlns:a16="http://schemas.microsoft.com/office/drawing/2014/main" id="{544BA93B-ECEE-4F15-D94B-C334B01275B7}"/>
-              </a:ext>
-            </a:extLst>
-          </p:cNvPr>
-          <p:cNvSpPr>
-            <a:spLocks noGrp="1"/>
-          </p:cNvSpPr>
-          <p:nvPr>
-            <p:ph type="dt" sz="half" idx="10"/>
-          </p:nvPr>
-        </p:nvSpPr>
-        <p:spPr/>
-        <p:txBody>
-          <a:bodyPr/>
-          <a:lstStyle/>
-          <a:p>
-            <a:fld id="{5B984578-FC4A-4BC5-A56E-8C608487780F}" type="datetime1">
-              <a:rPr lang="it-IT" smtClean="0"/>
-              <a:t>03/01/2026</a:t>
-            </a:fld>
-            <a:endParaRPr lang="en-US"/>
-          </a:p>
-        </p:txBody>
-      </p:sp>
-      <p:sp>
-        <p:nvSpPr>
-          <p:cNvPr id="6" name="Footer Placeholder 5">
-            <a:extLst>
-              <a:ext uri="{FF2B5EF4-FFF2-40B4-BE49-F238E27FC236}">
-                <a16:creationId xmlns:a16="http://schemas.microsoft.com/office/drawing/2014/main" id="{9D233D3A-3D73-C032-F75B-02CE82B2998C}"/>
-              </a:ext>
-            </a:extLst>
-          </p:cNvPr>
-          <p:cNvSpPr>
-            <a:spLocks noGrp="1"/>
-          </p:cNvSpPr>
-          <p:nvPr>
-            <p:ph type="ftr" sz="quarter" idx="11"/>
-          </p:nvPr>
-        </p:nvSpPr>
-        <p:spPr/>
-        <p:txBody>
-          <a:bodyPr/>
-          <a:lstStyle/>
-          <a:p>
-            <a:r>
-              <a:rPr lang="nn-NO"/>
-              <a:t>DINO MENG [SM3201466], BsC AIDA@MIGE</a:t>
-            </a:r>
-            <a:endParaRPr lang="en-US"/>
-          </a:p>
-        </p:txBody>
-      </p:sp>
-      <p:sp>
-        <p:nvSpPr>
-          <p:cNvPr id="7" name="Slide Number Placeholder 6">
-            <a:extLst>
-              <a:ext uri="{FF2B5EF4-FFF2-40B4-BE49-F238E27FC236}">
-                <a16:creationId xmlns:a16="http://schemas.microsoft.com/office/drawing/2014/main" id="{18AEDF5E-071A-9EF2-4F0B-F1A2F9CEFAB8}"/>
-              </a:ext>
-            </a:extLst>
-          </p:cNvPr>
-          <p:cNvSpPr>
-            <a:spLocks noGrp="1"/>
-          </p:cNvSpPr>
-          <p:nvPr>
-            <p:ph type="sldNum" sz="quarter" idx="12"/>
-          </p:nvPr>
-        </p:nvSpPr>
-        <p:spPr/>
-        <p:txBody>
-          <a:bodyPr/>
-          <a:lstStyle/>
-          <a:p>
-            <a:fld id="{8BF32AC9-143A-477E-841D-1F801B7F8FE8}" type="slidenum">
-              <a:rPr lang="en-US" smtClean="0"/>
-              <a:t>25</a:t>
-            </a:fld>
-            <a:endParaRPr lang="en-US"/>
-          </a:p>
-        </p:txBody>
-      </p:sp>
-      <p:pic>
-        <p:nvPicPr>
-          <p:cNvPr id="10" name="Picture 9" descr="A graph of a sound wave&#10;&#10;AI-generated content may be incorrect.">
-            <a:extLst>
-              <a:ext uri="{FF2B5EF4-FFF2-40B4-BE49-F238E27FC236}">
-                <a16:creationId xmlns:a16="http://schemas.microsoft.com/office/drawing/2014/main" id="{644F473F-2078-AD6E-2303-3291CBD0651E}"/>
-              </a:ext>
-            </a:extLst>
-          </p:cNvPr>
-          <p:cNvPicPr>
-            <a:picLocks noChangeAspect="1"/>
-          </p:cNvPicPr>
-          <p:nvPr/>
-        </p:nvPicPr>
-        <p:blipFill>
-          <a:blip r:embed="rId2"/>
-          <a:stretch>
-            <a:fillRect/>
-          </a:stretch>
-        </p:blipFill>
-        <p:spPr>
-          <a:xfrm>
-            <a:off x="1338261" y="1436711"/>
-            <a:ext cx="9515475" cy="4552950"/>
-          </a:xfrm>
-          <a:prstGeom prst="rect">
-            <a:avLst/>
-          </a:prstGeom>
-        </p:spPr>
-      </p:pic>
-    </p:spTree>
-    <p:extLst>
-      <p:ext uri="{BB962C8B-B14F-4D97-AF65-F5344CB8AC3E}">
-        <p14:creationId xmlns:p14="http://schemas.microsoft.com/office/powerpoint/2010/main" val="3663038567"/>
-      </p:ext>
-    </p:extLst>
-  </p:cSld>
-  <p:clrMapOvr>
-    <a:masterClrMapping/>
-  </p:clrMapOvr>
-</p:sld>
-</file>
-
-<file path=ppt/slides/slide26.xml><?xml version="1.0" encoding="utf-8"?>
-<p:sld xmlns:a="http://schemas.openxmlformats.org/drawingml/2006/main" xmlns:r="http://schemas.openxmlformats.org/officeDocument/2006/relationships" xmlns:p="http://schemas.openxmlformats.org/presentationml/2006/main">
-  <p:cSld>
-    <p:spTree>
-      <p:nvGrpSpPr>
-        <p:cNvPr id="1" name="">
-          <a:extLst>
-            <a:ext uri="{FF2B5EF4-FFF2-40B4-BE49-F238E27FC236}">
-              <a16:creationId xmlns:a16="http://schemas.microsoft.com/office/drawing/2014/main" id="{729FE9A4-6EA0-3AB3-6F89-BE1990D2F7BA}"/>
-            </a:ext>
-          </a:extLst>
-        </p:cNvPr>
-        <p:cNvGrpSpPr/>
-        <p:nvPr/>
-      </p:nvGrpSpPr>
-      <p:grpSpPr>
-        <a:xfrm>
-          <a:off x="0" y="0"/>
-          <a:ext cx="0" cy="0"/>
-          <a:chOff x="0" y="0"/>
-          <a:chExt cx="0" cy="0"/>
-        </a:xfrm>
-      </p:grpSpPr>
-      <p:sp>
-        <p:nvSpPr>
-          <p:cNvPr id="3" name="TextBox 2">
-            <a:extLst>
-              <a:ext uri="{FF2B5EF4-FFF2-40B4-BE49-F238E27FC236}">
-                <a16:creationId xmlns:a16="http://schemas.microsoft.com/office/drawing/2014/main" id="{97B0DD3E-4157-B76F-9987-D1CD9DC5873B}"/>
-              </a:ext>
-            </a:extLst>
-          </p:cNvPr>
-          <p:cNvSpPr txBox="1"/>
-          <p:nvPr/>
-        </p:nvSpPr>
-        <p:spPr>
-          <a:xfrm>
-            <a:off x="688257" y="442035"/>
-            <a:ext cx="5407743" cy="523220"/>
-          </a:xfrm>
-          <a:prstGeom prst="rect">
-            <a:avLst/>
-          </a:prstGeom>
-          <a:noFill/>
-        </p:spPr>
-        <p:txBody>
-          <a:bodyPr wrap="square">
-            <a:spAutoFit/>
-          </a:bodyPr>
-          <a:lstStyle/>
-          <a:p>
-            <a:r>
-              <a:rPr lang="it-IT" sz="2800" b="1" dirty="0"/>
-              <a:t>APPROFONDIMENTO SU W2</a:t>
-            </a:r>
-          </a:p>
-        </p:txBody>
-      </p:sp>
-      <p:sp>
-        <p:nvSpPr>
-          <p:cNvPr id="4" name="Rectangle 3">
-            <a:extLst>
-              <a:ext uri="{FF2B5EF4-FFF2-40B4-BE49-F238E27FC236}">
-                <a16:creationId xmlns:a16="http://schemas.microsoft.com/office/drawing/2014/main" id="{5CF43595-52D0-D7A0-717D-FDCAAB81CCE5}"/>
-              </a:ext>
-            </a:extLst>
-          </p:cNvPr>
-          <p:cNvSpPr/>
-          <p:nvPr/>
-        </p:nvSpPr>
-        <p:spPr>
-          <a:xfrm>
-            <a:off x="688257" y="965255"/>
-            <a:ext cx="10815485" cy="104767"/>
-          </a:xfrm>
-          <a:prstGeom prst="rect">
-            <a:avLst/>
-          </a:prstGeom>
-          <a:solidFill>
-            <a:schemeClr val="accent4"/>
-          </a:solidFill>
-          <a:ln>
-            <a:noFill/>
-          </a:ln>
-        </p:spPr>
-        <p:style>
-          <a:lnRef idx="2">
-            <a:schemeClr val="accent1">
-              <a:shade val="15000"/>
-            </a:schemeClr>
-          </a:lnRef>
-          <a:fillRef idx="1">
-            <a:schemeClr val="accent1"/>
-          </a:fillRef>
-          <a:effectRef idx="0">
-            <a:schemeClr val="accent1"/>
-          </a:effectRef>
-          <a:fontRef idx="minor">
-            <a:schemeClr val="lt1"/>
-          </a:fontRef>
-        </p:style>
-        <p:txBody>
-          <a:bodyPr rtlCol="0" anchor="ctr"/>
-          <a:lstStyle/>
-          <a:p>
-            <a:pPr algn="ctr"/>
-            <a:endParaRPr lang="en-US"/>
-          </a:p>
-        </p:txBody>
-      </p:sp>
-      <p:sp>
-        <p:nvSpPr>
-          <p:cNvPr id="9" name="TextBox 8">
-            <a:extLst>
-              <a:ext uri="{FF2B5EF4-FFF2-40B4-BE49-F238E27FC236}">
-                <a16:creationId xmlns:a16="http://schemas.microsoft.com/office/drawing/2014/main" id="{BCA882A3-E78C-B2BA-6C34-867AB5F7AA15}"/>
-              </a:ext>
-            </a:extLst>
-          </p:cNvPr>
-          <p:cNvSpPr txBox="1"/>
-          <p:nvPr/>
-        </p:nvSpPr>
-        <p:spPr>
-          <a:xfrm>
-            <a:off x="6959599" y="514495"/>
-            <a:ext cx="4544143" cy="461665"/>
-          </a:xfrm>
-          <a:prstGeom prst="rect">
-            <a:avLst/>
-          </a:prstGeom>
-          <a:noFill/>
-        </p:spPr>
-        <p:txBody>
-          <a:bodyPr wrap="square">
-            <a:spAutoFit/>
-          </a:bodyPr>
-          <a:lstStyle/>
-          <a:p>
-            <a:pPr algn="r"/>
-            <a:r>
-              <a:rPr lang="it-IT" sz="2400" b="1" i="1" dirty="0"/>
-              <a:t>Step: Confronto dei risultati</a:t>
-            </a:r>
-          </a:p>
-        </p:txBody>
-      </p:sp>
-      <p:sp>
-        <p:nvSpPr>
-          <p:cNvPr id="2" name="TextBox 1">
-            <a:extLst>
-              <a:ext uri="{FF2B5EF4-FFF2-40B4-BE49-F238E27FC236}">
-                <a16:creationId xmlns:a16="http://schemas.microsoft.com/office/drawing/2014/main" id="{5229A26A-3C47-D1AB-FDA1-B2AF227D8AB0}"/>
-              </a:ext>
-            </a:extLst>
-          </p:cNvPr>
-          <p:cNvSpPr txBox="1"/>
-          <p:nvPr/>
-        </p:nvSpPr>
-        <p:spPr>
-          <a:xfrm>
-            <a:off x="688257" y="1257642"/>
-            <a:ext cx="10028904" cy="3046988"/>
-          </a:xfrm>
-          <a:prstGeom prst="rect">
-            <a:avLst/>
-          </a:prstGeom>
-          <a:noFill/>
-        </p:spPr>
-        <p:txBody>
-          <a:bodyPr wrap="square" rtlCol="0">
-            <a:spAutoFit/>
-          </a:bodyPr>
-          <a:lstStyle/>
-          <a:p>
-            <a:pPr marL="285750" indent="-285750">
-              <a:buFont typeface="Wingdings" panose="05000000000000000000" pitchFamily="2" charset="2"/>
-              <a:buChar char="q"/>
-            </a:pPr>
-            <a:r>
-              <a:rPr lang="it-IT" sz="2400" dirty="0">
-                <a:latin typeface="Arial" panose="020B0604020202020204" pitchFamily="34" charset="0"/>
-                <a:cs typeface="Arial" panose="020B0604020202020204" pitchFamily="34" charset="0"/>
-              </a:rPr>
-              <a:t>Implicazioni</a:t>
-            </a:r>
-          </a:p>
-          <a:p>
-            <a:pPr marL="742950" lvl="1" indent="-285750">
-              <a:buFont typeface="Wingdings" panose="05000000000000000000" pitchFamily="2" charset="2"/>
-              <a:buChar char="q"/>
-            </a:pPr>
-            <a:r>
-              <a:rPr lang="it-IT" sz="2400" dirty="0">
-                <a:latin typeface="Arial" panose="020B0604020202020204" pitchFamily="34" charset="0"/>
-                <a:cs typeface="Arial" panose="020B0604020202020204" pitchFamily="34" charset="0"/>
-              </a:rPr>
-              <a:t>In realtà W2 non era mai LAS</a:t>
-            </a:r>
-          </a:p>
-          <a:p>
-            <a:pPr marL="1200150" lvl="2" indent="-285750">
-              <a:buFont typeface="Wingdings" panose="05000000000000000000" pitchFamily="2" charset="2"/>
-              <a:buChar char="q"/>
-            </a:pPr>
-            <a:r>
-              <a:rPr lang="it-IT" sz="2400" dirty="0">
-                <a:latin typeface="Arial" panose="020B0604020202020204" pitchFamily="34" charset="0"/>
-                <a:cs typeface="Arial" panose="020B0604020202020204" pitchFamily="34" charset="0"/>
-              </a:rPr>
-              <a:t>A discapito delle apparenze e quanto proposto nel paper</a:t>
-            </a:r>
-          </a:p>
-          <a:p>
-            <a:pPr marL="1200150" lvl="2" indent="-285750">
-              <a:buFont typeface="Wingdings" panose="05000000000000000000" pitchFamily="2" charset="2"/>
-              <a:buChar char="q"/>
-            </a:pPr>
-            <a:endParaRPr lang="it-IT" sz="2400" dirty="0">
-              <a:latin typeface="Arial" panose="020B0604020202020204" pitchFamily="34" charset="0"/>
-              <a:cs typeface="Arial" panose="020B0604020202020204" pitchFamily="34" charset="0"/>
-            </a:endParaRPr>
-          </a:p>
-          <a:p>
-            <a:pPr marL="285750" indent="-285750">
-              <a:buFont typeface="Wingdings" panose="05000000000000000000" pitchFamily="2" charset="2"/>
-              <a:buChar char="q"/>
-            </a:pPr>
-            <a:r>
-              <a:rPr lang="it-IT" sz="2400" dirty="0">
-                <a:latin typeface="Arial" panose="020B0604020202020204" pitchFamily="34" charset="0"/>
-                <a:cs typeface="Arial" panose="020B0604020202020204" pitchFamily="34" charset="0"/>
-              </a:rPr>
-              <a:t>Per confermare che non sia noise dovuto al risolutore:</a:t>
-            </a:r>
-          </a:p>
-          <a:p>
-            <a:pPr marL="742950" lvl="1" indent="-285750">
-              <a:buFont typeface="Wingdings" panose="05000000000000000000" pitchFamily="2" charset="2"/>
-              <a:buChar char="q"/>
-            </a:pPr>
-            <a:r>
-              <a:rPr lang="it-IT" sz="2400" dirty="0">
-                <a:latin typeface="Arial" panose="020B0604020202020204" pitchFamily="34" charset="0"/>
-                <a:cs typeface="Arial" panose="020B0604020202020204" pitchFamily="34" charset="0"/>
-              </a:rPr>
-              <a:t>Rieffettuato l’esperimento con metodi numerici diversi</a:t>
-            </a:r>
-          </a:p>
-          <a:p>
-            <a:pPr marL="742950" lvl="1" indent="-285750">
-              <a:buFont typeface="Wingdings" panose="05000000000000000000" pitchFamily="2" charset="2"/>
-              <a:buChar char="q"/>
-            </a:pPr>
-            <a:r>
-              <a:rPr lang="it-IT" sz="2400" dirty="0">
-                <a:latin typeface="Arial" panose="020B0604020202020204" pitchFamily="34" charset="0"/>
-                <a:cs typeface="Arial" panose="020B0604020202020204" pitchFamily="34" charset="0"/>
-              </a:rPr>
-              <a:t>Stessi risultati, confermato</a:t>
-            </a:r>
-          </a:p>
-          <a:p>
-            <a:pPr marL="742950" lvl="1" indent="-285750">
-              <a:buFont typeface="Wingdings" panose="05000000000000000000" pitchFamily="2" charset="2"/>
-              <a:buChar char="q"/>
-            </a:pPr>
-            <a:endParaRPr lang="it-IT" sz="2400" dirty="0">
-              <a:latin typeface="Arial" panose="020B0604020202020204" pitchFamily="34" charset="0"/>
-              <a:cs typeface="Arial" panose="020B0604020202020204" pitchFamily="34" charset="0"/>
-            </a:endParaRPr>
-          </a:p>
-        </p:txBody>
-      </p:sp>
-      <p:sp>
-        <p:nvSpPr>
-          <p:cNvPr id="5" name="Date Placeholder 4">
-            <a:extLst>
-              <a:ext uri="{FF2B5EF4-FFF2-40B4-BE49-F238E27FC236}">
-                <a16:creationId xmlns:a16="http://schemas.microsoft.com/office/drawing/2014/main" id="{2ED846B0-B38C-A692-E9A3-FFA97B60385E}"/>
-              </a:ext>
-            </a:extLst>
-          </p:cNvPr>
-          <p:cNvSpPr>
-            <a:spLocks noGrp="1"/>
-          </p:cNvSpPr>
-          <p:nvPr>
-            <p:ph type="dt" sz="half" idx="10"/>
-          </p:nvPr>
-        </p:nvSpPr>
-        <p:spPr/>
-        <p:txBody>
-          <a:bodyPr/>
-          <a:lstStyle/>
-          <a:p>
-            <a:fld id="{C5E77C2B-364A-4D71-8BAD-691E9BD64FFE}" type="datetime1">
-              <a:rPr lang="it-IT" smtClean="0"/>
-              <a:t>03/01/2026</a:t>
-            </a:fld>
-            <a:endParaRPr lang="en-US"/>
-          </a:p>
-        </p:txBody>
-      </p:sp>
-      <p:sp>
-        <p:nvSpPr>
-          <p:cNvPr id="6" name="Footer Placeholder 5">
-            <a:extLst>
-              <a:ext uri="{FF2B5EF4-FFF2-40B4-BE49-F238E27FC236}">
-                <a16:creationId xmlns:a16="http://schemas.microsoft.com/office/drawing/2014/main" id="{F9469EB7-D049-4D97-ECD0-F3AE4915CDA4}"/>
-              </a:ext>
-            </a:extLst>
-          </p:cNvPr>
-          <p:cNvSpPr>
-            <a:spLocks noGrp="1"/>
-          </p:cNvSpPr>
-          <p:nvPr>
-            <p:ph type="ftr" sz="quarter" idx="11"/>
-          </p:nvPr>
-        </p:nvSpPr>
-        <p:spPr/>
-        <p:txBody>
-          <a:bodyPr/>
-          <a:lstStyle/>
-          <a:p>
-            <a:r>
-              <a:rPr lang="nn-NO"/>
-              <a:t>DINO MENG [SM3201466], BsC AIDA@MIGE</a:t>
-            </a:r>
-            <a:endParaRPr lang="en-US"/>
-          </a:p>
-        </p:txBody>
-      </p:sp>
-      <p:sp>
-        <p:nvSpPr>
-          <p:cNvPr id="7" name="Slide Number Placeholder 6">
-            <a:extLst>
-              <a:ext uri="{FF2B5EF4-FFF2-40B4-BE49-F238E27FC236}">
-                <a16:creationId xmlns:a16="http://schemas.microsoft.com/office/drawing/2014/main" id="{2FF40AED-F76D-795E-5333-A4B81466833A}"/>
-              </a:ext>
-            </a:extLst>
-          </p:cNvPr>
-          <p:cNvSpPr>
-            <a:spLocks noGrp="1"/>
-          </p:cNvSpPr>
-          <p:nvPr>
-            <p:ph type="sldNum" sz="quarter" idx="12"/>
-          </p:nvPr>
-        </p:nvSpPr>
-        <p:spPr/>
-        <p:txBody>
-          <a:bodyPr/>
-          <a:lstStyle/>
-          <a:p>
-            <a:fld id="{8BF32AC9-143A-477E-841D-1F801B7F8FE8}" type="slidenum">
-              <a:rPr lang="en-US" smtClean="0"/>
-              <a:t>26</a:t>
-            </a:fld>
-            <a:endParaRPr lang="en-US"/>
-          </a:p>
-        </p:txBody>
-      </p:sp>
-    </p:spTree>
-    <p:extLst>
-      <p:ext uri="{BB962C8B-B14F-4D97-AF65-F5344CB8AC3E}">
-        <p14:creationId xmlns:p14="http://schemas.microsoft.com/office/powerpoint/2010/main" val="393239306"/>
-      </p:ext>
-    </p:extLst>
-  </p:cSld>
-  <p:clrMapOvr>
-    <a:masterClrMapping/>
-  </p:clrMapOvr>
-</p:sld>
-</file>
-
-<file path=ppt/slides/slide27.xml><?xml version="1.0" encoding="utf-8"?>
-<p:sld xmlns:a="http://schemas.openxmlformats.org/drawingml/2006/main" xmlns:r="http://schemas.openxmlformats.org/officeDocument/2006/relationships" xmlns:p="http://schemas.openxmlformats.org/presentationml/2006/main">
-  <p:cSld>
-    <p:spTree>
-      <p:nvGrpSpPr>
-        <p:cNvPr id="1" name="">
-          <a:extLst>
-            <a:ext uri="{FF2B5EF4-FFF2-40B4-BE49-F238E27FC236}">
-              <a16:creationId xmlns:a16="http://schemas.microsoft.com/office/drawing/2014/main" id="{DDC630C4-A2E7-4675-A543-9FEFEB48C66F}"/>
-            </a:ext>
-          </a:extLst>
-        </p:cNvPr>
-        <p:cNvGrpSpPr/>
-        <p:nvPr/>
-      </p:nvGrpSpPr>
-      <p:grpSpPr>
-        <a:xfrm>
-          <a:off x="0" y="0"/>
-          <a:ext cx="0" cy="0"/>
-          <a:chOff x="0" y="0"/>
-          <a:chExt cx="0" cy="0"/>
-        </a:xfrm>
-      </p:grpSpPr>
-      <p:sp>
-        <p:nvSpPr>
-          <p:cNvPr id="3" name="TextBox 2">
-            <a:extLst>
-              <a:ext uri="{FF2B5EF4-FFF2-40B4-BE49-F238E27FC236}">
-                <a16:creationId xmlns:a16="http://schemas.microsoft.com/office/drawing/2014/main" id="{AA900290-CEF3-1C84-ED74-6C905D2E8C39}"/>
-              </a:ext>
-            </a:extLst>
-          </p:cNvPr>
-          <p:cNvSpPr txBox="1"/>
-          <p:nvPr/>
-        </p:nvSpPr>
-        <p:spPr>
-          <a:xfrm>
-            <a:off x="688257" y="442035"/>
-            <a:ext cx="5407743" cy="523220"/>
-          </a:xfrm>
-          <a:prstGeom prst="rect">
-            <a:avLst/>
-          </a:prstGeom>
-          <a:noFill/>
-        </p:spPr>
-        <p:txBody>
-          <a:bodyPr wrap="square">
-            <a:spAutoFit/>
-          </a:bodyPr>
-          <a:lstStyle/>
-          <a:p>
-            <a:r>
-              <a:rPr lang="it-IT" sz="2800" b="1" dirty="0"/>
-              <a:t>ULTERIORI SPERIMENTAZIONI </a:t>
-            </a:r>
-          </a:p>
-        </p:txBody>
-      </p:sp>
-      <p:sp>
-        <p:nvSpPr>
-          <p:cNvPr id="4" name="Rectangle 3">
-            <a:extLst>
-              <a:ext uri="{FF2B5EF4-FFF2-40B4-BE49-F238E27FC236}">
-                <a16:creationId xmlns:a16="http://schemas.microsoft.com/office/drawing/2014/main" id="{A296E94F-3EDF-85B5-9FE9-C83560FAD80A}"/>
-              </a:ext>
-            </a:extLst>
-          </p:cNvPr>
-          <p:cNvSpPr/>
-          <p:nvPr/>
-        </p:nvSpPr>
-        <p:spPr>
-          <a:xfrm>
-            <a:off x="688257" y="965255"/>
-            <a:ext cx="10815485" cy="104767"/>
-          </a:xfrm>
-          <a:prstGeom prst="rect">
-            <a:avLst/>
-          </a:prstGeom>
-          <a:solidFill>
-            <a:schemeClr val="accent4"/>
-          </a:solidFill>
-          <a:ln>
-            <a:noFill/>
-          </a:ln>
-        </p:spPr>
-        <p:style>
-          <a:lnRef idx="2">
-            <a:schemeClr val="accent1">
-              <a:shade val="15000"/>
-            </a:schemeClr>
-          </a:lnRef>
-          <a:fillRef idx="1">
-            <a:schemeClr val="accent1"/>
-          </a:fillRef>
-          <a:effectRef idx="0">
-            <a:schemeClr val="accent1"/>
-          </a:effectRef>
-          <a:fontRef idx="minor">
-            <a:schemeClr val="lt1"/>
-          </a:fontRef>
-        </p:style>
-        <p:txBody>
-          <a:bodyPr rtlCol="0" anchor="ctr"/>
-          <a:lstStyle/>
-          <a:p>
-            <a:pPr algn="ctr"/>
-            <a:endParaRPr lang="en-US"/>
-          </a:p>
-        </p:txBody>
-      </p:sp>
-      <p:sp>
-        <p:nvSpPr>
-          <p:cNvPr id="9" name="TextBox 8">
-            <a:extLst>
-              <a:ext uri="{FF2B5EF4-FFF2-40B4-BE49-F238E27FC236}">
-                <a16:creationId xmlns:a16="http://schemas.microsoft.com/office/drawing/2014/main" id="{FE8E974E-5D79-EAAD-8215-1CA8EB2ACDE4}"/>
-              </a:ext>
-            </a:extLst>
-          </p:cNvPr>
-          <p:cNvSpPr txBox="1"/>
-          <p:nvPr/>
-        </p:nvSpPr>
-        <p:spPr>
-          <a:xfrm>
-            <a:off x="6959599" y="514495"/>
-            <a:ext cx="4544143" cy="461665"/>
-          </a:xfrm>
-          <a:prstGeom prst="rect">
-            <a:avLst/>
-          </a:prstGeom>
-          <a:noFill/>
-        </p:spPr>
-        <p:txBody>
-          <a:bodyPr wrap="square">
-            <a:spAutoFit/>
-          </a:bodyPr>
-          <a:lstStyle/>
-          <a:p>
-            <a:pPr algn="r"/>
-            <a:r>
-              <a:rPr lang="it-IT" sz="2400" b="1" i="1" dirty="0"/>
               <a:t>Step: More stuff</a:t>
             </a:r>
           </a:p>
@@ -11222,7 +10571,7 @@
           <a:p>
             <a:fld id="{C6EF02CD-913D-490D-9F2F-9D6BDCD607B3}" type="datetime1">
               <a:rPr lang="it-IT" smtClean="0"/>
-              <a:t>03/01/2026</a:t>
+              <a:t>04/01/2026</a:t>
             </a:fld>
             <a:endParaRPr lang="en-US"/>
           </a:p>
@@ -11280,7 +10629,7 @@
           <a:p>
             <a:fld id="{8BF32AC9-143A-477E-841D-1F801B7F8FE8}" type="slidenum">
               <a:rPr lang="en-US" smtClean="0"/>
-              <a:t>27</a:t>
+              <a:t>25</a:t>
             </a:fld>
             <a:endParaRPr lang="en-US"/>
           </a:p>
@@ -11359,7 +10708,7 @@
 </p:sld>
 </file>
 
-<file path=ppt/slides/slide28.xml><?xml version="1.0" encoding="utf-8"?>
+<file path=ppt/slides/slide26.xml><?xml version="1.0" encoding="utf-8"?>
 <p:sld xmlns:a="http://schemas.openxmlformats.org/drawingml/2006/main" xmlns:r="http://schemas.openxmlformats.org/officeDocument/2006/relationships" xmlns:p="http://schemas.openxmlformats.org/presentationml/2006/main">
   <p:cSld>
     <p:spTree>
@@ -11505,8 +10854,8 @@
           </a:p>
         </p:txBody>
       </p:sp>
-      <mc:AlternateContent xmlns:mc="http://schemas.openxmlformats.org/markup-compatibility/2006">
-        <mc:Choice xmlns:a14="http://schemas.microsoft.com/office/drawing/2010/main" Requires="a14">
+      <mc:AlternateContent xmlns:mc="http://schemas.openxmlformats.org/markup-compatibility/2006" xmlns:a14="http://schemas.microsoft.com/office/drawing/2010/main">
+        <mc:Choice Requires="a14">
           <p:sp>
             <p:nvSpPr>
               <p:cNvPr id="2" name="TextBox 1">
@@ -11705,7 +11054,7 @@
             </p:txBody>
           </p:sp>
         </mc:Choice>
-        <mc:Fallback>
+        <mc:Fallback xmlns="">
           <p:sp>
             <p:nvSpPr>
               <p:cNvPr id="2" name="TextBox 1">
@@ -11773,7 +11122,7 @@
           <a:p>
             <a:fld id="{C6EF02CD-913D-490D-9F2F-9D6BDCD607B3}" type="datetime1">
               <a:rPr lang="it-IT" smtClean="0"/>
-              <a:t>03/01/2026</a:t>
+              <a:t>04/01/2026</a:t>
             </a:fld>
             <a:endParaRPr lang="en-US"/>
           </a:p>
@@ -11831,7 +11180,7 @@
           <a:p>
             <a:fld id="{8BF32AC9-143A-477E-841D-1F801B7F8FE8}" type="slidenum">
               <a:rPr lang="en-US" smtClean="0"/>
-              <a:t>28</a:t>
+              <a:t>26</a:t>
             </a:fld>
             <a:endParaRPr lang="en-US"/>
           </a:p>
@@ -11850,7 +11199,7 @@
 </p:sld>
 </file>
 
-<file path=ppt/slides/slide29.xml><?xml version="1.0" encoding="utf-8"?>
+<file path=ppt/slides/slide27.xml><?xml version="1.0" encoding="utf-8"?>
 <p:sld xmlns:a="http://schemas.openxmlformats.org/drawingml/2006/main" xmlns:r="http://schemas.openxmlformats.org/officeDocument/2006/relationships" xmlns:p="http://schemas.openxmlformats.org/presentationml/2006/main">
   <p:cSld>
     <p:spTree>
@@ -12023,7 +11372,7 @@
           <a:p>
             <a:fld id="{C6EF02CD-913D-490D-9F2F-9D6BDCD607B3}" type="datetime1">
               <a:rPr lang="it-IT" smtClean="0"/>
-              <a:t>03/01/2026</a:t>
+              <a:t>04/01/2026</a:t>
             </a:fld>
             <a:endParaRPr lang="en-US"/>
           </a:p>
@@ -12081,7 +11430,7 @@
           <a:p>
             <a:fld id="{8BF32AC9-143A-477E-841D-1F801B7F8FE8}" type="slidenum">
               <a:rPr lang="en-US" smtClean="0"/>
-              <a:t>29</a:t>
+              <a:t>27</a:t>
             </a:fld>
             <a:endParaRPr lang="en-US"/>
           </a:p>
@@ -12117,8 +11466,8 @@
           </a:prstGeom>
         </p:spPr>
       </p:pic>
-      <mc:AlternateContent xmlns:mc="http://schemas.openxmlformats.org/markup-compatibility/2006">
-        <mc:Choice xmlns:a14="http://schemas.microsoft.com/office/drawing/2010/main" Requires="a14">
+      <mc:AlternateContent xmlns:mc="http://schemas.openxmlformats.org/markup-compatibility/2006" xmlns:a14="http://schemas.microsoft.com/office/drawing/2010/main">
+        <mc:Choice Requires="a14">
           <p:sp>
             <p:nvSpPr>
               <p:cNvPr id="12" name="TextBox 11">
@@ -12311,7 +11660,7 @@
             </p:txBody>
           </p:sp>
         </mc:Choice>
-        <mc:Fallback>
+        <mc:Fallback xmlns="">
           <p:sp>
             <p:nvSpPr>
               <p:cNvPr id="12" name="TextBox 11">
@@ -12369,7 +11718,7 @@
 </p:sld>
 </file>
 
-<file path=ppt/slides/slide3.xml><?xml version="1.0" encoding="utf-8"?>
+<file path=ppt/slides/slide28.xml><?xml version="1.0" encoding="utf-8"?>
 <p:sld xmlns:a="http://schemas.openxmlformats.org/drawingml/2006/main" xmlns:r="http://schemas.openxmlformats.org/officeDocument/2006/relationships" xmlns:p="http://schemas.openxmlformats.org/presentationml/2006/main">
   <p:cSld>
     <p:spTree>
@@ -12377,7 +11726,7 @@
         <p:cNvPr id="1" name="">
           <a:extLst>
             <a:ext uri="{FF2B5EF4-FFF2-40B4-BE49-F238E27FC236}">
-              <a16:creationId xmlns:a16="http://schemas.microsoft.com/office/drawing/2014/main" id="{9B83727E-27C8-3BC2-0BE9-6E847212FD24}"/>
+              <a16:creationId xmlns:a16="http://schemas.microsoft.com/office/drawing/2014/main" id="{96E5363B-C443-2C30-76AC-1A20ED6B1343}"/>
             </a:ext>
           </a:extLst>
         </p:cNvPr>
@@ -12397,7 +11746,7 @@
           <p:cNvPr id="3" name="TextBox 2">
             <a:extLst>
               <a:ext uri="{FF2B5EF4-FFF2-40B4-BE49-F238E27FC236}">
-                <a16:creationId xmlns:a16="http://schemas.microsoft.com/office/drawing/2014/main" id="{7CAC9E22-B53F-66C9-EC08-8C202BDA41B1}"/>
+                <a16:creationId xmlns:a16="http://schemas.microsoft.com/office/drawing/2014/main" id="{18D8A499-2D61-3350-373E-8EBD281DB141}"/>
               </a:ext>
             </a:extLst>
           </p:cNvPr>
@@ -12407,7 +11756,7 @@
         <p:spPr>
           <a:xfrm>
             <a:off x="688257" y="442035"/>
-            <a:ext cx="4991183" cy="523220"/>
+            <a:ext cx="5407743" cy="523220"/>
           </a:xfrm>
           <a:prstGeom prst="rect">
             <a:avLst/>
@@ -12422,7 +11771,11 @@
           <a:p>
             <a:r>
               <a:rPr lang="it-IT" sz="2800" b="1" dirty="0"/>
-              <a:t>OBBIETTIVI</a:t>
+              <a:t>FATTORE </a:t>
+            </a:r>
+            <a:r>
+              <a:rPr lang="el-GR" sz="2800" b="1" dirty="0"/>
+              <a:t>𝜎</a:t>
             </a:r>
           </a:p>
         </p:txBody>
@@ -12432,7 +11785,7 @@
           <p:cNvPr id="4" name="Rectangle 3">
             <a:extLst>
               <a:ext uri="{FF2B5EF4-FFF2-40B4-BE49-F238E27FC236}">
-                <a16:creationId xmlns:a16="http://schemas.microsoft.com/office/drawing/2014/main" id="{1A8E64B5-1412-B215-45FD-678D251A3117}"/>
+                <a16:creationId xmlns:a16="http://schemas.microsoft.com/office/drawing/2014/main" id="{55BBA5D8-A77B-7A34-15A4-D5765E556311}"/>
               </a:ext>
             </a:extLst>
           </p:cNvPr>
@@ -12479,8 +11832,682 @@
           </a:p>
         </p:txBody>
       </p:sp>
-      <mc:AlternateContent xmlns:mc="http://schemas.openxmlformats.org/markup-compatibility/2006">
-        <mc:Choice xmlns:a14="http://schemas.microsoft.com/office/drawing/2010/main" Requires="a14">
+      <p:sp>
+        <p:nvSpPr>
+          <p:cNvPr id="9" name="TextBox 8">
+            <a:extLst>
+              <a:ext uri="{FF2B5EF4-FFF2-40B4-BE49-F238E27FC236}">
+                <a16:creationId xmlns:a16="http://schemas.microsoft.com/office/drawing/2014/main" id="{6662678C-7842-9FB1-14CE-5E5831F4C67F}"/>
+              </a:ext>
+            </a:extLst>
+          </p:cNvPr>
+          <p:cNvSpPr txBox="1"/>
+          <p:nvPr/>
+        </p:nvSpPr>
+        <p:spPr>
+          <a:xfrm>
+            <a:off x="6959599" y="514495"/>
+            <a:ext cx="4544143" cy="461665"/>
+          </a:xfrm>
+          <a:prstGeom prst="rect">
+            <a:avLst/>
+          </a:prstGeom>
+          <a:noFill/>
+        </p:spPr>
+        <p:txBody>
+          <a:bodyPr wrap="square">
+            <a:spAutoFit/>
+          </a:bodyPr>
+          <a:lstStyle/>
+          <a:p>
+            <a:pPr algn="r"/>
+            <a:r>
+              <a:rPr lang="it-IT" sz="2400" b="1" i="1" dirty="0"/>
+              <a:t>Step: More stuff</a:t>
+            </a:r>
+          </a:p>
+        </p:txBody>
+      </p:sp>
+      <p:sp>
+        <p:nvSpPr>
+          <p:cNvPr id="5" name="Date Placeholder 4">
+            <a:extLst>
+              <a:ext uri="{FF2B5EF4-FFF2-40B4-BE49-F238E27FC236}">
+                <a16:creationId xmlns:a16="http://schemas.microsoft.com/office/drawing/2014/main" id="{4324BAF3-B0FA-49A4-4F07-372D1C29CD81}"/>
+              </a:ext>
+            </a:extLst>
+          </p:cNvPr>
+          <p:cNvSpPr>
+            <a:spLocks noGrp="1"/>
+          </p:cNvSpPr>
+          <p:nvPr>
+            <p:ph type="dt" sz="half" idx="10"/>
+          </p:nvPr>
+        </p:nvSpPr>
+        <p:spPr/>
+        <p:txBody>
+          <a:bodyPr/>
+          <a:lstStyle/>
+          <a:p>
+            <a:fld id="{C6EF02CD-913D-490D-9F2F-9D6BDCD607B3}" type="datetime1">
+              <a:rPr lang="it-IT" smtClean="0"/>
+              <a:t>04/01/2026</a:t>
+            </a:fld>
+            <a:endParaRPr lang="en-US"/>
+          </a:p>
+        </p:txBody>
+      </p:sp>
+      <p:sp>
+        <p:nvSpPr>
+          <p:cNvPr id="6" name="Footer Placeholder 5">
+            <a:extLst>
+              <a:ext uri="{FF2B5EF4-FFF2-40B4-BE49-F238E27FC236}">
+                <a16:creationId xmlns:a16="http://schemas.microsoft.com/office/drawing/2014/main" id="{24AAAAC8-FFC7-7B63-19BE-AF2B8C10509F}"/>
+              </a:ext>
+            </a:extLst>
+          </p:cNvPr>
+          <p:cNvSpPr>
+            <a:spLocks noGrp="1"/>
+          </p:cNvSpPr>
+          <p:nvPr>
+            <p:ph type="ftr" sz="quarter" idx="11"/>
+          </p:nvPr>
+        </p:nvSpPr>
+        <p:spPr/>
+        <p:txBody>
+          <a:bodyPr/>
+          <a:lstStyle/>
+          <a:p>
+            <a:r>
+              <a:rPr lang="nn-NO"/>
+              <a:t>DINO MENG [SM3201466], BsC AIDA@MIGE</a:t>
+            </a:r>
+            <a:endParaRPr lang="en-US"/>
+          </a:p>
+        </p:txBody>
+      </p:sp>
+      <p:sp>
+        <p:nvSpPr>
+          <p:cNvPr id="7" name="Slide Number Placeholder 6">
+            <a:extLst>
+              <a:ext uri="{FF2B5EF4-FFF2-40B4-BE49-F238E27FC236}">
+                <a16:creationId xmlns:a16="http://schemas.microsoft.com/office/drawing/2014/main" id="{6B6A1E7B-5B7F-2BF9-E56B-74329CFAE4FD}"/>
+              </a:ext>
+            </a:extLst>
+          </p:cNvPr>
+          <p:cNvSpPr>
+            <a:spLocks noGrp="1"/>
+          </p:cNvSpPr>
+          <p:nvPr>
+            <p:ph type="sldNum" sz="quarter" idx="12"/>
+          </p:nvPr>
+        </p:nvSpPr>
+        <p:spPr/>
+        <p:txBody>
+          <a:bodyPr/>
+          <a:lstStyle/>
+          <a:p>
+            <a:fld id="{8BF32AC9-143A-477E-841D-1F801B7F8FE8}" type="slidenum">
+              <a:rPr lang="en-US" smtClean="0"/>
+              <a:t>28</a:t>
+            </a:fld>
+            <a:endParaRPr lang="en-US"/>
+          </a:p>
+        </p:txBody>
+      </p:sp>
+      <mc:AlternateContent xmlns:mc="http://schemas.openxmlformats.org/markup-compatibility/2006" xmlns:a14="http://schemas.microsoft.com/office/drawing/2010/main">
+        <mc:Choice Requires="a14">
+          <p:sp>
+            <p:nvSpPr>
+              <p:cNvPr id="12" name="TextBox 11">
+                <a:extLst>
+                  <a:ext uri="{FF2B5EF4-FFF2-40B4-BE49-F238E27FC236}">
+                    <a16:creationId xmlns:a16="http://schemas.microsoft.com/office/drawing/2014/main" id="{8D3955B6-A31B-BE5E-7BDD-21C6641EF41B}"/>
+                  </a:ext>
+                </a:extLst>
+              </p:cNvPr>
+              <p:cNvSpPr txBox="1"/>
+              <p:nvPr/>
+            </p:nvSpPr>
+            <p:spPr>
+              <a:xfrm>
+                <a:off x="6213010" y="1983429"/>
+                <a:ext cx="5447687" cy="1200329"/>
+              </a:xfrm>
+              <a:prstGeom prst="rect">
+                <a:avLst/>
+              </a:prstGeom>
+              <a:noFill/>
+            </p:spPr>
+            <p:txBody>
+              <a:bodyPr wrap="square">
+                <a:spAutoFit/>
+              </a:bodyPr>
+              <a:lstStyle/>
+              <a:p>
+                <a:pPr marL="285750" indent="-285750">
+                  <a:buFont typeface="Wingdings" panose="05000000000000000000" pitchFamily="2" charset="2"/>
+                  <a:buChar char="q"/>
+                </a:pPr>
+                <a:r>
+                  <a:rPr lang="it-IT" sz="2400" dirty="0">
+                    <a:latin typeface="Arial" panose="020B0604020202020204" pitchFamily="34" charset="0"/>
+                    <a:cs typeface="Arial" panose="020B0604020202020204" pitchFamily="34" charset="0"/>
+                  </a:rPr>
+                  <a:t>Risultato analogo per </a:t>
+                </a:r>
+                <a14:m>
+                  <m:oMath xmlns:m="http://schemas.openxmlformats.org/officeDocument/2006/math">
+                    <m:r>
+                      <a:rPr lang="it-IT" sz="2400" i="1">
+                        <a:latin typeface="Cambria Math" panose="02040503050406030204" pitchFamily="18" charset="0"/>
+                        <a:cs typeface="Arial" panose="020B0604020202020204" pitchFamily="34" charset="0"/>
+                      </a:rPr>
+                      <m:t>𝜎</m:t>
+                    </m:r>
+                  </m:oMath>
+                </a14:m>
+                <a:endParaRPr lang="it-IT" sz="2400" dirty="0">
+                  <a:latin typeface="Arial" panose="020B0604020202020204" pitchFamily="34" charset="0"/>
+                  <a:cs typeface="Arial" panose="020B0604020202020204" pitchFamily="34" charset="0"/>
+                </a:endParaRPr>
+              </a:p>
+              <a:p>
+                <a:pPr marL="742950" lvl="1" indent="-285750">
+                  <a:buFont typeface="Wingdings" panose="05000000000000000000" pitchFamily="2" charset="2"/>
+                  <a:buChar char="q"/>
+                </a:pPr>
+                <a:r>
+                  <a:rPr lang="it-IT" sz="2400" dirty="0">
+                    <a:latin typeface="Arial" panose="020B0604020202020204" pitchFamily="34" charset="0"/>
+                    <a:cs typeface="Arial" panose="020B0604020202020204" pitchFamily="34" charset="0"/>
+                  </a:rPr>
+                  <a:t>Questa volta fatto variare «solo» in [0,10]</a:t>
+                </a:r>
+              </a:p>
+            </p:txBody>
+          </p:sp>
+        </mc:Choice>
+        <mc:Fallback xmlns="">
+          <p:sp>
+            <p:nvSpPr>
+              <p:cNvPr id="12" name="TextBox 11">
+                <a:extLst>
+                  <a:ext uri="{FF2B5EF4-FFF2-40B4-BE49-F238E27FC236}">
+                    <a16:creationId xmlns:a16="http://schemas.microsoft.com/office/drawing/2014/main" id="{8D3955B6-A31B-BE5E-7BDD-21C6641EF41B}"/>
+                  </a:ext>
+                </a:extLst>
+              </p:cNvPr>
+              <p:cNvSpPr txBox="1">
+                <a:spLocks noRot="1" noChangeAspect="1" noMove="1" noResize="1" noEditPoints="1" noAdjustHandles="1" noChangeArrowheads="1" noChangeShapeType="1" noTextEdit="1"/>
+              </p:cNvSpPr>
+              <p:nvPr/>
+            </p:nvSpPr>
+            <p:spPr>
+              <a:xfrm>
+                <a:off x="6213010" y="1983429"/>
+                <a:ext cx="5447687" cy="1200329"/>
+              </a:xfrm>
+              <a:prstGeom prst="rect">
+                <a:avLst/>
+              </a:prstGeom>
+              <a:blipFill>
+                <a:blip r:embed="rId2"/>
+                <a:stretch>
+                  <a:fillRect l="-1454" t="-3553" r="-895" b="-11168"/>
+                </a:stretch>
+              </a:blipFill>
+            </p:spPr>
+            <p:txBody>
+              <a:bodyPr/>
+              <a:lstStyle/>
+              <a:p>
+                <a:r>
+                  <a:rPr lang="en-US">
+                    <a:noFill/>
+                  </a:rPr>
+                  <a:t> </a:t>
+                </a:r>
+              </a:p>
+            </p:txBody>
+          </p:sp>
+        </mc:Fallback>
+      </mc:AlternateContent>
+      <p:pic>
+        <p:nvPicPr>
+          <p:cNvPr id="13" name="Picture 12" descr="A diagram of a graph&#10;&#10;AI-generated content may be incorrect.">
+            <a:extLst>
+              <a:ext uri="{FF2B5EF4-FFF2-40B4-BE49-F238E27FC236}">
+                <a16:creationId xmlns:a16="http://schemas.microsoft.com/office/drawing/2014/main" id="{B2263EAB-BD24-3C41-ED62-87EE15141122}"/>
+              </a:ext>
+            </a:extLst>
+          </p:cNvPr>
+          <p:cNvPicPr>
+            <a:picLocks noChangeAspect="1"/>
+          </p:cNvPicPr>
+          <p:nvPr/>
+        </p:nvPicPr>
+        <p:blipFill>
+          <a:blip r:embed="rId3"/>
+          <a:stretch>
+            <a:fillRect/>
+          </a:stretch>
+        </p:blipFill>
+        <p:spPr>
+          <a:xfrm>
+            <a:off x="688257" y="1416015"/>
+            <a:ext cx="5353050" cy="4572000"/>
+          </a:xfrm>
+          <a:prstGeom prst="rect">
+            <a:avLst/>
+          </a:prstGeom>
+        </p:spPr>
+      </p:pic>
+    </p:spTree>
+    <p:extLst>
+      <p:ext uri="{BB962C8B-B14F-4D97-AF65-F5344CB8AC3E}">
+        <p14:creationId xmlns:p14="http://schemas.microsoft.com/office/powerpoint/2010/main" val="4047128178"/>
+      </p:ext>
+    </p:extLst>
+  </p:cSld>
+  <p:clrMapOvr>
+    <a:masterClrMapping/>
+  </p:clrMapOvr>
+</p:sld>
+</file>
+
+<file path=ppt/slides/slide29.xml><?xml version="1.0" encoding="utf-8"?>
+<p:sld xmlns:a="http://schemas.openxmlformats.org/drawingml/2006/main" xmlns:r="http://schemas.openxmlformats.org/officeDocument/2006/relationships" xmlns:p="http://schemas.openxmlformats.org/presentationml/2006/main">
+  <p:cSld>
+    <p:spTree>
+      <p:nvGrpSpPr>
+        <p:cNvPr id="1" name="">
+          <a:extLst>
+            <a:ext uri="{FF2B5EF4-FFF2-40B4-BE49-F238E27FC236}">
+              <a16:creationId xmlns:a16="http://schemas.microsoft.com/office/drawing/2014/main" id="{B74B6A40-D661-9A26-0E43-D4D937EBCC3F}"/>
+            </a:ext>
+          </a:extLst>
+        </p:cNvPr>
+        <p:cNvGrpSpPr/>
+        <p:nvPr/>
+      </p:nvGrpSpPr>
+      <p:grpSpPr>
+        <a:xfrm>
+          <a:off x="0" y="0"/>
+          <a:ext cx="0" cy="0"/>
+          <a:chOff x="0" y="0"/>
+          <a:chExt cx="0" cy="0"/>
+        </a:xfrm>
+      </p:grpSpPr>
+      <p:sp>
+        <p:nvSpPr>
+          <p:cNvPr id="3" name="TextBox 2">
+            <a:extLst>
+              <a:ext uri="{FF2B5EF4-FFF2-40B4-BE49-F238E27FC236}">
+                <a16:creationId xmlns:a16="http://schemas.microsoft.com/office/drawing/2014/main" id="{18F2C9DA-85F0-4279-745E-F5A7627C2113}"/>
+              </a:ext>
+            </a:extLst>
+          </p:cNvPr>
+          <p:cNvSpPr txBox="1"/>
+          <p:nvPr/>
+        </p:nvSpPr>
+        <p:spPr>
+          <a:xfrm>
+            <a:off x="688257" y="442035"/>
+            <a:ext cx="5407743" cy="523220"/>
+          </a:xfrm>
+          <a:prstGeom prst="rect">
+            <a:avLst/>
+          </a:prstGeom>
+          <a:noFill/>
+        </p:spPr>
+        <p:txBody>
+          <a:bodyPr wrap="square">
+            <a:spAutoFit/>
+          </a:bodyPr>
+          <a:lstStyle/>
+          <a:p>
+            <a:r>
+              <a:rPr lang="it-IT" sz="2800" b="1" dirty="0"/>
+              <a:t>FATTORE </a:t>
+            </a:r>
+            <a:r>
+              <a:rPr lang="el-GR" sz="2800" b="1" dirty="0"/>
+              <a:t>𝜎</a:t>
+            </a:r>
+          </a:p>
+        </p:txBody>
+      </p:sp>
+      <p:sp>
+        <p:nvSpPr>
+          <p:cNvPr id="4" name="Rectangle 3">
+            <a:extLst>
+              <a:ext uri="{FF2B5EF4-FFF2-40B4-BE49-F238E27FC236}">
+                <a16:creationId xmlns:a16="http://schemas.microsoft.com/office/drawing/2014/main" id="{A8C17A29-B201-8A6E-5DFB-AF2E0F3F1329}"/>
+              </a:ext>
+            </a:extLst>
+          </p:cNvPr>
+          <p:cNvSpPr/>
+          <p:nvPr/>
+        </p:nvSpPr>
+        <p:spPr>
+          <a:xfrm>
+            <a:off x="688257" y="965255"/>
+            <a:ext cx="10815485" cy="104767"/>
+          </a:xfrm>
+          <a:prstGeom prst="rect">
+            <a:avLst/>
+          </a:prstGeom>
+          <a:solidFill>
+            <a:schemeClr val="accent4"/>
+          </a:solidFill>
+          <a:ln>
+            <a:noFill/>
+          </a:ln>
+        </p:spPr>
+        <p:style>
+          <a:lnRef idx="2">
+            <a:schemeClr val="accent1">
+              <a:shade val="15000"/>
+            </a:schemeClr>
+          </a:lnRef>
+          <a:fillRef idx="1">
+            <a:schemeClr val="accent1"/>
+          </a:fillRef>
+          <a:effectRef idx="0">
+            <a:schemeClr val="accent1"/>
+          </a:effectRef>
+          <a:fontRef idx="minor">
+            <a:schemeClr val="lt1"/>
+          </a:fontRef>
+        </p:style>
+        <p:txBody>
+          <a:bodyPr rtlCol="0" anchor="ctr"/>
+          <a:lstStyle/>
+          <a:p>
+            <a:pPr algn="ctr"/>
+            <a:endParaRPr lang="en-US"/>
+          </a:p>
+        </p:txBody>
+      </p:sp>
+      <p:sp>
+        <p:nvSpPr>
+          <p:cNvPr id="9" name="TextBox 8">
+            <a:extLst>
+              <a:ext uri="{FF2B5EF4-FFF2-40B4-BE49-F238E27FC236}">
+                <a16:creationId xmlns:a16="http://schemas.microsoft.com/office/drawing/2014/main" id="{26ADCA7A-CA30-93E7-807D-37D345A7EF64}"/>
+              </a:ext>
+            </a:extLst>
+          </p:cNvPr>
+          <p:cNvSpPr txBox="1"/>
+          <p:nvPr/>
+        </p:nvSpPr>
+        <p:spPr>
+          <a:xfrm>
+            <a:off x="6959599" y="514495"/>
+            <a:ext cx="4544143" cy="461665"/>
+          </a:xfrm>
+          <a:prstGeom prst="rect">
+            <a:avLst/>
+          </a:prstGeom>
+          <a:noFill/>
+        </p:spPr>
+        <p:txBody>
+          <a:bodyPr wrap="square">
+            <a:spAutoFit/>
+          </a:bodyPr>
+          <a:lstStyle/>
+          <a:p>
+            <a:pPr algn="r"/>
+            <a:r>
+              <a:rPr lang="it-IT" sz="2400" b="1" i="1" dirty="0"/>
+              <a:t>Step: More stuff</a:t>
+            </a:r>
+          </a:p>
+        </p:txBody>
+      </p:sp>
+      <p:sp>
+        <p:nvSpPr>
+          <p:cNvPr id="5" name="Date Placeholder 4">
+            <a:extLst>
+              <a:ext uri="{FF2B5EF4-FFF2-40B4-BE49-F238E27FC236}">
+                <a16:creationId xmlns:a16="http://schemas.microsoft.com/office/drawing/2014/main" id="{B6164E64-4683-F6B2-A4E8-3147F1ED829E}"/>
+              </a:ext>
+            </a:extLst>
+          </p:cNvPr>
+          <p:cNvSpPr>
+            <a:spLocks noGrp="1"/>
+          </p:cNvSpPr>
+          <p:nvPr>
+            <p:ph type="dt" sz="half" idx="10"/>
+          </p:nvPr>
+        </p:nvSpPr>
+        <p:spPr/>
+        <p:txBody>
+          <a:bodyPr/>
+          <a:lstStyle/>
+          <a:p>
+            <a:fld id="{C6EF02CD-913D-490D-9F2F-9D6BDCD607B3}" type="datetime1">
+              <a:rPr lang="it-IT" smtClean="0"/>
+              <a:t>04/01/2026</a:t>
+            </a:fld>
+            <a:endParaRPr lang="en-US"/>
+          </a:p>
+        </p:txBody>
+      </p:sp>
+      <p:sp>
+        <p:nvSpPr>
+          <p:cNvPr id="6" name="Footer Placeholder 5">
+            <a:extLst>
+              <a:ext uri="{FF2B5EF4-FFF2-40B4-BE49-F238E27FC236}">
+                <a16:creationId xmlns:a16="http://schemas.microsoft.com/office/drawing/2014/main" id="{95A6F43F-BCD3-A849-551B-FD5B61092448}"/>
+              </a:ext>
+            </a:extLst>
+          </p:cNvPr>
+          <p:cNvSpPr>
+            <a:spLocks noGrp="1"/>
+          </p:cNvSpPr>
+          <p:nvPr>
+            <p:ph type="ftr" sz="quarter" idx="11"/>
+          </p:nvPr>
+        </p:nvSpPr>
+        <p:spPr/>
+        <p:txBody>
+          <a:bodyPr/>
+          <a:lstStyle/>
+          <a:p>
+            <a:r>
+              <a:rPr lang="nn-NO"/>
+              <a:t>DINO MENG [SM3201466], BsC AIDA@MIGE</a:t>
+            </a:r>
+            <a:endParaRPr lang="en-US"/>
+          </a:p>
+        </p:txBody>
+      </p:sp>
+      <p:sp>
+        <p:nvSpPr>
+          <p:cNvPr id="7" name="Slide Number Placeholder 6">
+            <a:extLst>
+              <a:ext uri="{FF2B5EF4-FFF2-40B4-BE49-F238E27FC236}">
+                <a16:creationId xmlns:a16="http://schemas.microsoft.com/office/drawing/2014/main" id="{B0F95E78-CE82-F067-7EBD-C1EB7772B1B7}"/>
+              </a:ext>
+            </a:extLst>
+          </p:cNvPr>
+          <p:cNvSpPr>
+            <a:spLocks noGrp="1"/>
+          </p:cNvSpPr>
+          <p:nvPr>
+            <p:ph type="sldNum" sz="quarter" idx="12"/>
+          </p:nvPr>
+        </p:nvSpPr>
+        <p:spPr/>
+        <p:txBody>
+          <a:bodyPr/>
+          <a:lstStyle/>
+          <a:p>
+            <a:fld id="{8BF32AC9-143A-477E-841D-1F801B7F8FE8}" type="slidenum">
+              <a:rPr lang="en-US" smtClean="0"/>
+              <a:t>29</a:t>
+            </a:fld>
+            <a:endParaRPr lang="en-US"/>
+          </a:p>
+        </p:txBody>
+      </p:sp>
+      <p:pic>
+        <p:nvPicPr>
+          <p:cNvPr id="8" name="Picture 7" descr="A graph of different colored lines&#10;&#10;AI-generated content may be incorrect.">
+            <a:extLst>
+              <a:ext uri="{FF2B5EF4-FFF2-40B4-BE49-F238E27FC236}">
+                <a16:creationId xmlns:a16="http://schemas.microsoft.com/office/drawing/2014/main" id="{55C000E7-208C-EC4A-1744-A812B88A24F4}"/>
+              </a:ext>
+            </a:extLst>
+          </p:cNvPr>
+          <p:cNvPicPr>
+            <a:picLocks noChangeAspect="1"/>
+          </p:cNvPicPr>
+          <p:nvPr/>
+        </p:nvPicPr>
+        <p:blipFill>
+          <a:blip r:embed="rId2"/>
+          <a:stretch>
+            <a:fillRect/>
+          </a:stretch>
+        </p:blipFill>
+        <p:spPr>
+          <a:xfrm>
+            <a:off x="1150340" y="1416015"/>
+            <a:ext cx="9891320" cy="4629817"/>
+          </a:xfrm>
+          <a:prstGeom prst="rect">
+            <a:avLst/>
+          </a:prstGeom>
+        </p:spPr>
+      </p:pic>
+    </p:spTree>
+    <p:extLst>
+      <p:ext uri="{BB962C8B-B14F-4D97-AF65-F5344CB8AC3E}">
+        <p14:creationId xmlns:p14="http://schemas.microsoft.com/office/powerpoint/2010/main" val="202612540"/>
+      </p:ext>
+    </p:extLst>
+  </p:cSld>
+  <p:clrMapOvr>
+    <a:masterClrMapping/>
+  </p:clrMapOvr>
+</p:sld>
+</file>
+
+<file path=ppt/slides/slide3.xml><?xml version="1.0" encoding="utf-8"?>
+<p:sld xmlns:a="http://schemas.openxmlformats.org/drawingml/2006/main" xmlns:r="http://schemas.openxmlformats.org/officeDocument/2006/relationships" xmlns:p="http://schemas.openxmlformats.org/presentationml/2006/main">
+  <p:cSld>
+    <p:spTree>
+      <p:nvGrpSpPr>
+        <p:cNvPr id="1" name="">
+          <a:extLst>
+            <a:ext uri="{FF2B5EF4-FFF2-40B4-BE49-F238E27FC236}">
+              <a16:creationId xmlns:a16="http://schemas.microsoft.com/office/drawing/2014/main" id="{9B83727E-27C8-3BC2-0BE9-6E847212FD24}"/>
+            </a:ext>
+          </a:extLst>
+        </p:cNvPr>
+        <p:cNvGrpSpPr/>
+        <p:nvPr/>
+      </p:nvGrpSpPr>
+      <p:grpSpPr>
+        <a:xfrm>
+          <a:off x="0" y="0"/>
+          <a:ext cx="0" cy="0"/>
+          <a:chOff x="0" y="0"/>
+          <a:chExt cx="0" cy="0"/>
+        </a:xfrm>
+      </p:grpSpPr>
+      <p:sp>
+        <p:nvSpPr>
+          <p:cNvPr id="3" name="TextBox 2">
+            <a:extLst>
+              <a:ext uri="{FF2B5EF4-FFF2-40B4-BE49-F238E27FC236}">
+                <a16:creationId xmlns:a16="http://schemas.microsoft.com/office/drawing/2014/main" id="{7CAC9E22-B53F-66C9-EC08-8C202BDA41B1}"/>
+              </a:ext>
+            </a:extLst>
+          </p:cNvPr>
+          <p:cNvSpPr txBox="1"/>
+          <p:nvPr/>
+        </p:nvSpPr>
+        <p:spPr>
+          <a:xfrm>
+            <a:off x="688257" y="442035"/>
+            <a:ext cx="4991183" cy="523220"/>
+          </a:xfrm>
+          <a:prstGeom prst="rect">
+            <a:avLst/>
+          </a:prstGeom>
+          <a:noFill/>
+        </p:spPr>
+        <p:txBody>
+          <a:bodyPr wrap="square">
+            <a:spAutoFit/>
+          </a:bodyPr>
+          <a:lstStyle/>
+          <a:p>
+            <a:r>
+              <a:rPr lang="it-IT" sz="2800" b="1" dirty="0"/>
+              <a:t>OBBIETTIVI</a:t>
+            </a:r>
+          </a:p>
+        </p:txBody>
+      </p:sp>
+      <p:sp>
+        <p:nvSpPr>
+          <p:cNvPr id="4" name="Rectangle 3">
+            <a:extLst>
+              <a:ext uri="{FF2B5EF4-FFF2-40B4-BE49-F238E27FC236}">
+                <a16:creationId xmlns:a16="http://schemas.microsoft.com/office/drawing/2014/main" id="{1A8E64B5-1412-B215-45FD-678D251A3117}"/>
+              </a:ext>
+            </a:extLst>
+          </p:cNvPr>
+          <p:cNvSpPr/>
+          <p:nvPr/>
+        </p:nvSpPr>
+        <p:spPr>
+          <a:xfrm>
+            <a:off x="688257" y="965255"/>
+            <a:ext cx="10815485" cy="104767"/>
+          </a:xfrm>
+          <a:prstGeom prst="rect">
+            <a:avLst/>
+          </a:prstGeom>
+          <a:solidFill>
+            <a:schemeClr val="accent4"/>
+          </a:solidFill>
+          <a:ln>
+            <a:noFill/>
+          </a:ln>
+        </p:spPr>
+        <p:style>
+          <a:lnRef idx="2">
+            <a:schemeClr val="accent1">
+              <a:shade val="15000"/>
+            </a:schemeClr>
+          </a:lnRef>
+          <a:fillRef idx="1">
+            <a:schemeClr val="accent1"/>
+          </a:fillRef>
+          <a:effectRef idx="0">
+            <a:schemeClr val="accent1"/>
+          </a:effectRef>
+          <a:fontRef idx="minor">
+            <a:schemeClr val="lt1"/>
+          </a:fontRef>
+        </p:style>
+        <p:txBody>
+          <a:bodyPr rtlCol="0" anchor="ctr"/>
+          <a:lstStyle/>
+          <a:p>
+            <a:pPr algn="ctr"/>
+            <a:endParaRPr lang="en-US"/>
+          </a:p>
+        </p:txBody>
+      </p:sp>
+      <mc:AlternateContent xmlns:mc="http://schemas.openxmlformats.org/markup-compatibility/2006" xmlns:a14="http://schemas.microsoft.com/office/drawing/2010/main">
+        <mc:Choice Requires="a14">
           <p:sp>
             <p:nvSpPr>
               <p:cNvPr id="7" name="TextBox 6">
@@ -12682,7 +12709,7 @@
             </p:txBody>
           </p:sp>
         </mc:Choice>
-        <mc:Fallback>
+        <mc:Fallback xmlns="">
           <p:sp>
             <p:nvSpPr>
               <p:cNvPr id="7" name="TextBox 6">
@@ -12750,7 +12777,7 @@
           <a:p>
             <a:fld id="{27A3E659-987F-4162-B81F-7A5AC08EB42B}" type="datetime1">
               <a:rPr lang="it-IT" smtClean="0"/>
-              <a:t>03/01/2026</a:t>
+              <a:t>04/01/2026</a:t>
             </a:fld>
             <a:endParaRPr lang="en-US"/>
           </a:p>
@@ -12818,684 +12845,6 @@
     <p:extLst>
       <p:ext uri="{BB962C8B-B14F-4D97-AF65-F5344CB8AC3E}">
         <p14:creationId xmlns:p14="http://schemas.microsoft.com/office/powerpoint/2010/main" val="11954351"/>
-      </p:ext>
-    </p:extLst>
-  </p:cSld>
-  <p:clrMapOvr>
-    <a:masterClrMapping/>
-  </p:clrMapOvr>
-</p:sld>
-</file>
-
-<file path=ppt/slides/slide30.xml><?xml version="1.0" encoding="utf-8"?>
-<p:sld xmlns:a="http://schemas.openxmlformats.org/drawingml/2006/main" xmlns:r="http://schemas.openxmlformats.org/officeDocument/2006/relationships" xmlns:p="http://schemas.openxmlformats.org/presentationml/2006/main">
-  <p:cSld>
-    <p:spTree>
-      <p:nvGrpSpPr>
-        <p:cNvPr id="1" name="">
-          <a:extLst>
-            <a:ext uri="{FF2B5EF4-FFF2-40B4-BE49-F238E27FC236}">
-              <a16:creationId xmlns:a16="http://schemas.microsoft.com/office/drawing/2014/main" id="{96E5363B-C443-2C30-76AC-1A20ED6B1343}"/>
-            </a:ext>
-          </a:extLst>
-        </p:cNvPr>
-        <p:cNvGrpSpPr/>
-        <p:nvPr/>
-      </p:nvGrpSpPr>
-      <p:grpSpPr>
-        <a:xfrm>
-          <a:off x="0" y="0"/>
-          <a:ext cx="0" cy="0"/>
-          <a:chOff x="0" y="0"/>
-          <a:chExt cx="0" cy="0"/>
-        </a:xfrm>
-      </p:grpSpPr>
-      <p:sp>
-        <p:nvSpPr>
-          <p:cNvPr id="3" name="TextBox 2">
-            <a:extLst>
-              <a:ext uri="{FF2B5EF4-FFF2-40B4-BE49-F238E27FC236}">
-                <a16:creationId xmlns:a16="http://schemas.microsoft.com/office/drawing/2014/main" id="{18D8A499-2D61-3350-373E-8EBD281DB141}"/>
-              </a:ext>
-            </a:extLst>
-          </p:cNvPr>
-          <p:cNvSpPr txBox="1"/>
-          <p:nvPr/>
-        </p:nvSpPr>
-        <p:spPr>
-          <a:xfrm>
-            <a:off x="688257" y="442035"/>
-            <a:ext cx="5407743" cy="523220"/>
-          </a:xfrm>
-          <a:prstGeom prst="rect">
-            <a:avLst/>
-          </a:prstGeom>
-          <a:noFill/>
-        </p:spPr>
-        <p:txBody>
-          <a:bodyPr wrap="square">
-            <a:spAutoFit/>
-          </a:bodyPr>
-          <a:lstStyle/>
-          <a:p>
-            <a:r>
-              <a:rPr lang="it-IT" sz="2800" b="1" dirty="0"/>
-              <a:t>FATTORE </a:t>
-            </a:r>
-            <a:r>
-              <a:rPr lang="el-GR" sz="2800" b="1" dirty="0"/>
-              <a:t>𝜎</a:t>
-            </a:r>
-          </a:p>
-        </p:txBody>
-      </p:sp>
-      <p:sp>
-        <p:nvSpPr>
-          <p:cNvPr id="4" name="Rectangle 3">
-            <a:extLst>
-              <a:ext uri="{FF2B5EF4-FFF2-40B4-BE49-F238E27FC236}">
-                <a16:creationId xmlns:a16="http://schemas.microsoft.com/office/drawing/2014/main" id="{55BBA5D8-A77B-7A34-15A4-D5765E556311}"/>
-              </a:ext>
-            </a:extLst>
-          </p:cNvPr>
-          <p:cNvSpPr/>
-          <p:nvPr/>
-        </p:nvSpPr>
-        <p:spPr>
-          <a:xfrm>
-            <a:off x="688257" y="965255"/>
-            <a:ext cx="10815485" cy="104767"/>
-          </a:xfrm>
-          <a:prstGeom prst="rect">
-            <a:avLst/>
-          </a:prstGeom>
-          <a:solidFill>
-            <a:schemeClr val="accent4"/>
-          </a:solidFill>
-          <a:ln>
-            <a:noFill/>
-          </a:ln>
-        </p:spPr>
-        <p:style>
-          <a:lnRef idx="2">
-            <a:schemeClr val="accent1">
-              <a:shade val="15000"/>
-            </a:schemeClr>
-          </a:lnRef>
-          <a:fillRef idx="1">
-            <a:schemeClr val="accent1"/>
-          </a:fillRef>
-          <a:effectRef idx="0">
-            <a:schemeClr val="accent1"/>
-          </a:effectRef>
-          <a:fontRef idx="minor">
-            <a:schemeClr val="lt1"/>
-          </a:fontRef>
-        </p:style>
-        <p:txBody>
-          <a:bodyPr rtlCol="0" anchor="ctr"/>
-          <a:lstStyle/>
-          <a:p>
-            <a:pPr algn="ctr"/>
-            <a:endParaRPr lang="en-US"/>
-          </a:p>
-        </p:txBody>
-      </p:sp>
-      <p:sp>
-        <p:nvSpPr>
-          <p:cNvPr id="9" name="TextBox 8">
-            <a:extLst>
-              <a:ext uri="{FF2B5EF4-FFF2-40B4-BE49-F238E27FC236}">
-                <a16:creationId xmlns:a16="http://schemas.microsoft.com/office/drawing/2014/main" id="{6662678C-7842-9FB1-14CE-5E5831F4C67F}"/>
-              </a:ext>
-            </a:extLst>
-          </p:cNvPr>
-          <p:cNvSpPr txBox="1"/>
-          <p:nvPr/>
-        </p:nvSpPr>
-        <p:spPr>
-          <a:xfrm>
-            <a:off x="6959599" y="514495"/>
-            <a:ext cx="4544143" cy="461665"/>
-          </a:xfrm>
-          <a:prstGeom prst="rect">
-            <a:avLst/>
-          </a:prstGeom>
-          <a:noFill/>
-        </p:spPr>
-        <p:txBody>
-          <a:bodyPr wrap="square">
-            <a:spAutoFit/>
-          </a:bodyPr>
-          <a:lstStyle/>
-          <a:p>
-            <a:pPr algn="r"/>
-            <a:r>
-              <a:rPr lang="it-IT" sz="2400" b="1" i="1" dirty="0"/>
-              <a:t>Step: More stuff</a:t>
-            </a:r>
-          </a:p>
-        </p:txBody>
-      </p:sp>
-      <p:sp>
-        <p:nvSpPr>
-          <p:cNvPr id="5" name="Date Placeholder 4">
-            <a:extLst>
-              <a:ext uri="{FF2B5EF4-FFF2-40B4-BE49-F238E27FC236}">
-                <a16:creationId xmlns:a16="http://schemas.microsoft.com/office/drawing/2014/main" id="{4324BAF3-B0FA-49A4-4F07-372D1C29CD81}"/>
-              </a:ext>
-            </a:extLst>
-          </p:cNvPr>
-          <p:cNvSpPr>
-            <a:spLocks noGrp="1"/>
-          </p:cNvSpPr>
-          <p:nvPr>
-            <p:ph type="dt" sz="half" idx="10"/>
-          </p:nvPr>
-        </p:nvSpPr>
-        <p:spPr/>
-        <p:txBody>
-          <a:bodyPr/>
-          <a:lstStyle/>
-          <a:p>
-            <a:fld id="{C6EF02CD-913D-490D-9F2F-9D6BDCD607B3}" type="datetime1">
-              <a:rPr lang="it-IT" smtClean="0"/>
-              <a:t>03/01/2026</a:t>
-            </a:fld>
-            <a:endParaRPr lang="en-US"/>
-          </a:p>
-        </p:txBody>
-      </p:sp>
-      <p:sp>
-        <p:nvSpPr>
-          <p:cNvPr id="6" name="Footer Placeholder 5">
-            <a:extLst>
-              <a:ext uri="{FF2B5EF4-FFF2-40B4-BE49-F238E27FC236}">
-                <a16:creationId xmlns:a16="http://schemas.microsoft.com/office/drawing/2014/main" id="{24AAAAC8-FFC7-7B63-19BE-AF2B8C10509F}"/>
-              </a:ext>
-            </a:extLst>
-          </p:cNvPr>
-          <p:cNvSpPr>
-            <a:spLocks noGrp="1"/>
-          </p:cNvSpPr>
-          <p:nvPr>
-            <p:ph type="ftr" sz="quarter" idx="11"/>
-          </p:nvPr>
-        </p:nvSpPr>
-        <p:spPr/>
-        <p:txBody>
-          <a:bodyPr/>
-          <a:lstStyle/>
-          <a:p>
-            <a:r>
-              <a:rPr lang="nn-NO"/>
-              <a:t>DINO MENG [SM3201466], BsC AIDA@MIGE</a:t>
-            </a:r>
-            <a:endParaRPr lang="en-US"/>
-          </a:p>
-        </p:txBody>
-      </p:sp>
-      <p:sp>
-        <p:nvSpPr>
-          <p:cNvPr id="7" name="Slide Number Placeholder 6">
-            <a:extLst>
-              <a:ext uri="{FF2B5EF4-FFF2-40B4-BE49-F238E27FC236}">
-                <a16:creationId xmlns:a16="http://schemas.microsoft.com/office/drawing/2014/main" id="{6B6A1E7B-5B7F-2BF9-E56B-74329CFAE4FD}"/>
-              </a:ext>
-            </a:extLst>
-          </p:cNvPr>
-          <p:cNvSpPr>
-            <a:spLocks noGrp="1"/>
-          </p:cNvSpPr>
-          <p:nvPr>
-            <p:ph type="sldNum" sz="quarter" idx="12"/>
-          </p:nvPr>
-        </p:nvSpPr>
-        <p:spPr/>
-        <p:txBody>
-          <a:bodyPr/>
-          <a:lstStyle/>
-          <a:p>
-            <a:fld id="{8BF32AC9-143A-477E-841D-1F801B7F8FE8}" type="slidenum">
-              <a:rPr lang="en-US" smtClean="0"/>
-              <a:t>30</a:t>
-            </a:fld>
-            <a:endParaRPr lang="en-US"/>
-          </a:p>
-        </p:txBody>
-      </p:sp>
-      <mc:AlternateContent xmlns:mc="http://schemas.openxmlformats.org/markup-compatibility/2006">
-        <mc:Choice xmlns:a14="http://schemas.microsoft.com/office/drawing/2010/main" Requires="a14">
-          <p:sp>
-            <p:nvSpPr>
-              <p:cNvPr id="12" name="TextBox 11">
-                <a:extLst>
-                  <a:ext uri="{FF2B5EF4-FFF2-40B4-BE49-F238E27FC236}">
-                    <a16:creationId xmlns:a16="http://schemas.microsoft.com/office/drawing/2014/main" id="{8D3955B6-A31B-BE5E-7BDD-21C6641EF41B}"/>
-                  </a:ext>
-                </a:extLst>
-              </p:cNvPr>
-              <p:cNvSpPr txBox="1"/>
-              <p:nvPr/>
-            </p:nvSpPr>
-            <p:spPr>
-              <a:xfrm>
-                <a:off x="6213010" y="1983429"/>
-                <a:ext cx="5447687" cy="1200329"/>
-              </a:xfrm>
-              <a:prstGeom prst="rect">
-                <a:avLst/>
-              </a:prstGeom>
-              <a:noFill/>
-            </p:spPr>
-            <p:txBody>
-              <a:bodyPr wrap="square">
-                <a:spAutoFit/>
-              </a:bodyPr>
-              <a:lstStyle/>
-              <a:p>
-                <a:pPr marL="285750" indent="-285750">
-                  <a:buFont typeface="Wingdings" panose="05000000000000000000" pitchFamily="2" charset="2"/>
-                  <a:buChar char="q"/>
-                </a:pPr>
-                <a:r>
-                  <a:rPr lang="it-IT" sz="2400" dirty="0">
-                    <a:latin typeface="Arial" panose="020B0604020202020204" pitchFamily="34" charset="0"/>
-                    <a:cs typeface="Arial" panose="020B0604020202020204" pitchFamily="34" charset="0"/>
-                  </a:rPr>
-                  <a:t>Risultato analogo per </a:t>
-                </a:r>
-                <a14:m>
-                  <m:oMath xmlns:m="http://schemas.openxmlformats.org/officeDocument/2006/math">
-                    <m:r>
-                      <a:rPr lang="it-IT" sz="2400" i="1">
-                        <a:latin typeface="Cambria Math" panose="02040503050406030204" pitchFamily="18" charset="0"/>
-                        <a:cs typeface="Arial" panose="020B0604020202020204" pitchFamily="34" charset="0"/>
-                      </a:rPr>
-                      <m:t>𝜎</m:t>
-                    </m:r>
-                  </m:oMath>
-                </a14:m>
-                <a:endParaRPr lang="it-IT" sz="2400" dirty="0">
-                  <a:latin typeface="Arial" panose="020B0604020202020204" pitchFamily="34" charset="0"/>
-                  <a:cs typeface="Arial" panose="020B0604020202020204" pitchFamily="34" charset="0"/>
-                </a:endParaRPr>
-              </a:p>
-              <a:p>
-                <a:pPr marL="742950" lvl="1" indent="-285750">
-                  <a:buFont typeface="Wingdings" panose="05000000000000000000" pitchFamily="2" charset="2"/>
-                  <a:buChar char="q"/>
-                </a:pPr>
-                <a:r>
-                  <a:rPr lang="it-IT" sz="2400" dirty="0">
-                    <a:latin typeface="Arial" panose="020B0604020202020204" pitchFamily="34" charset="0"/>
-                    <a:cs typeface="Arial" panose="020B0604020202020204" pitchFamily="34" charset="0"/>
-                  </a:rPr>
-                  <a:t>Questa volta fatto variare «solo» in [0,10]</a:t>
-                </a:r>
-              </a:p>
-            </p:txBody>
-          </p:sp>
-        </mc:Choice>
-        <mc:Fallback>
-          <p:sp>
-            <p:nvSpPr>
-              <p:cNvPr id="12" name="TextBox 11">
-                <a:extLst>
-                  <a:ext uri="{FF2B5EF4-FFF2-40B4-BE49-F238E27FC236}">
-                    <a16:creationId xmlns:a16="http://schemas.microsoft.com/office/drawing/2014/main" id="{8D3955B6-A31B-BE5E-7BDD-21C6641EF41B}"/>
-                  </a:ext>
-                </a:extLst>
-              </p:cNvPr>
-              <p:cNvSpPr txBox="1">
-                <a:spLocks noRot="1" noChangeAspect="1" noMove="1" noResize="1" noEditPoints="1" noAdjustHandles="1" noChangeArrowheads="1" noChangeShapeType="1" noTextEdit="1"/>
-              </p:cNvSpPr>
-              <p:nvPr/>
-            </p:nvSpPr>
-            <p:spPr>
-              <a:xfrm>
-                <a:off x="6213010" y="1983429"/>
-                <a:ext cx="5447687" cy="1200329"/>
-              </a:xfrm>
-              <a:prstGeom prst="rect">
-                <a:avLst/>
-              </a:prstGeom>
-              <a:blipFill>
-                <a:blip r:embed="rId2"/>
-                <a:stretch>
-                  <a:fillRect l="-1454" t="-3553" r="-895" b="-11168"/>
-                </a:stretch>
-              </a:blipFill>
-            </p:spPr>
-            <p:txBody>
-              <a:bodyPr/>
-              <a:lstStyle/>
-              <a:p>
-                <a:r>
-                  <a:rPr lang="en-US">
-                    <a:noFill/>
-                  </a:rPr>
-                  <a:t> </a:t>
-                </a:r>
-              </a:p>
-            </p:txBody>
-          </p:sp>
-        </mc:Fallback>
-      </mc:AlternateContent>
-      <p:pic>
-        <p:nvPicPr>
-          <p:cNvPr id="13" name="Picture 12" descr="A diagram of a graph&#10;&#10;AI-generated content may be incorrect.">
-            <a:extLst>
-              <a:ext uri="{FF2B5EF4-FFF2-40B4-BE49-F238E27FC236}">
-                <a16:creationId xmlns:a16="http://schemas.microsoft.com/office/drawing/2014/main" id="{B2263EAB-BD24-3C41-ED62-87EE15141122}"/>
-              </a:ext>
-            </a:extLst>
-          </p:cNvPr>
-          <p:cNvPicPr>
-            <a:picLocks noChangeAspect="1"/>
-          </p:cNvPicPr>
-          <p:nvPr/>
-        </p:nvPicPr>
-        <p:blipFill>
-          <a:blip r:embed="rId3"/>
-          <a:stretch>
-            <a:fillRect/>
-          </a:stretch>
-        </p:blipFill>
-        <p:spPr>
-          <a:xfrm>
-            <a:off x="688257" y="1416015"/>
-            <a:ext cx="5353050" cy="4572000"/>
-          </a:xfrm>
-          <a:prstGeom prst="rect">
-            <a:avLst/>
-          </a:prstGeom>
-        </p:spPr>
-      </p:pic>
-    </p:spTree>
-    <p:extLst>
-      <p:ext uri="{BB962C8B-B14F-4D97-AF65-F5344CB8AC3E}">
-        <p14:creationId xmlns:p14="http://schemas.microsoft.com/office/powerpoint/2010/main" val="4047128178"/>
-      </p:ext>
-    </p:extLst>
-  </p:cSld>
-  <p:clrMapOvr>
-    <a:masterClrMapping/>
-  </p:clrMapOvr>
-</p:sld>
-</file>
-
-<file path=ppt/slides/slide31.xml><?xml version="1.0" encoding="utf-8"?>
-<p:sld xmlns:a="http://schemas.openxmlformats.org/drawingml/2006/main" xmlns:r="http://schemas.openxmlformats.org/officeDocument/2006/relationships" xmlns:p="http://schemas.openxmlformats.org/presentationml/2006/main">
-  <p:cSld>
-    <p:spTree>
-      <p:nvGrpSpPr>
-        <p:cNvPr id="1" name="">
-          <a:extLst>
-            <a:ext uri="{FF2B5EF4-FFF2-40B4-BE49-F238E27FC236}">
-              <a16:creationId xmlns:a16="http://schemas.microsoft.com/office/drawing/2014/main" id="{B74B6A40-D661-9A26-0E43-D4D937EBCC3F}"/>
-            </a:ext>
-          </a:extLst>
-        </p:cNvPr>
-        <p:cNvGrpSpPr/>
-        <p:nvPr/>
-      </p:nvGrpSpPr>
-      <p:grpSpPr>
-        <a:xfrm>
-          <a:off x="0" y="0"/>
-          <a:ext cx="0" cy="0"/>
-          <a:chOff x="0" y="0"/>
-          <a:chExt cx="0" cy="0"/>
-        </a:xfrm>
-      </p:grpSpPr>
-      <p:sp>
-        <p:nvSpPr>
-          <p:cNvPr id="3" name="TextBox 2">
-            <a:extLst>
-              <a:ext uri="{FF2B5EF4-FFF2-40B4-BE49-F238E27FC236}">
-                <a16:creationId xmlns:a16="http://schemas.microsoft.com/office/drawing/2014/main" id="{18F2C9DA-85F0-4279-745E-F5A7627C2113}"/>
-              </a:ext>
-            </a:extLst>
-          </p:cNvPr>
-          <p:cNvSpPr txBox="1"/>
-          <p:nvPr/>
-        </p:nvSpPr>
-        <p:spPr>
-          <a:xfrm>
-            <a:off x="688257" y="442035"/>
-            <a:ext cx="5407743" cy="523220"/>
-          </a:xfrm>
-          <a:prstGeom prst="rect">
-            <a:avLst/>
-          </a:prstGeom>
-          <a:noFill/>
-        </p:spPr>
-        <p:txBody>
-          <a:bodyPr wrap="square">
-            <a:spAutoFit/>
-          </a:bodyPr>
-          <a:lstStyle/>
-          <a:p>
-            <a:r>
-              <a:rPr lang="it-IT" sz="2800" b="1" dirty="0"/>
-              <a:t>FATTORE </a:t>
-            </a:r>
-            <a:r>
-              <a:rPr lang="el-GR" sz="2800" b="1" dirty="0"/>
-              <a:t>𝜎</a:t>
-            </a:r>
-          </a:p>
-        </p:txBody>
-      </p:sp>
-      <p:sp>
-        <p:nvSpPr>
-          <p:cNvPr id="4" name="Rectangle 3">
-            <a:extLst>
-              <a:ext uri="{FF2B5EF4-FFF2-40B4-BE49-F238E27FC236}">
-                <a16:creationId xmlns:a16="http://schemas.microsoft.com/office/drawing/2014/main" id="{A8C17A29-B201-8A6E-5DFB-AF2E0F3F1329}"/>
-              </a:ext>
-            </a:extLst>
-          </p:cNvPr>
-          <p:cNvSpPr/>
-          <p:nvPr/>
-        </p:nvSpPr>
-        <p:spPr>
-          <a:xfrm>
-            <a:off x="688257" y="965255"/>
-            <a:ext cx="10815485" cy="104767"/>
-          </a:xfrm>
-          <a:prstGeom prst="rect">
-            <a:avLst/>
-          </a:prstGeom>
-          <a:solidFill>
-            <a:schemeClr val="accent4"/>
-          </a:solidFill>
-          <a:ln>
-            <a:noFill/>
-          </a:ln>
-        </p:spPr>
-        <p:style>
-          <a:lnRef idx="2">
-            <a:schemeClr val="accent1">
-              <a:shade val="15000"/>
-            </a:schemeClr>
-          </a:lnRef>
-          <a:fillRef idx="1">
-            <a:schemeClr val="accent1"/>
-          </a:fillRef>
-          <a:effectRef idx="0">
-            <a:schemeClr val="accent1"/>
-          </a:effectRef>
-          <a:fontRef idx="minor">
-            <a:schemeClr val="lt1"/>
-          </a:fontRef>
-        </p:style>
-        <p:txBody>
-          <a:bodyPr rtlCol="0" anchor="ctr"/>
-          <a:lstStyle/>
-          <a:p>
-            <a:pPr algn="ctr"/>
-            <a:endParaRPr lang="en-US"/>
-          </a:p>
-        </p:txBody>
-      </p:sp>
-      <p:sp>
-        <p:nvSpPr>
-          <p:cNvPr id="9" name="TextBox 8">
-            <a:extLst>
-              <a:ext uri="{FF2B5EF4-FFF2-40B4-BE49-F238E27FC236}">
-                <a16:creationId xmlns:a16="http://schemas.microsoft.com/office/drawing/2014/main" id="{26ADCA7A-CA30-93E7-807D-37D345A7EF64}"/>
-              </a:ext>
-            </a:extLst>
-          </p:cNvPr>
-          <p:cNvSpPr txBox="1"/>
-          <p:nvPr/>
-        </p:nvSpPr>
-        <p:spPr>
-          <a:xfrm>
-            <a:off x="6959599" y="514495"/>
-            <a:ext cx="4544143" cy="461665"/>
-          </a:xfrm>
-          <a:prstGeom prst="rect">
-            <a:avLst/>
-          </a:prstGeom>
-          <a:noFill/>
-        </p:spPr>
-        <p:txBody>
-          <a:bodyPr wrap="square">
-            <a:spAutoFit/>
-          </a:bodyPr>
-          <a:lstStyle/>
-          <a:p>
-            <a:pPr algn="r"/>
-            <a:r>
-              <a:rPr lang="it-IT" sz="2400" b="1" i="1" dirty="0"/>
-              <a:t>Step: More stuff</a:t>
-            </a:r>
-          </a:p>
-        </p:txBody>
-      </p:sp>
-      <p:sp>
-        <p:nvSpPr>
-          <p:cNvPr id="5" name="Date Placeholder 4">
-            <a:extLst>
-              <a:ext uri="{FF2B5EF4-FFF2-40B4-BE49-F238E27FC236}">
-                <a16:creationId xmlns:a16="http://schemas.microsoft.com/office/drawing/2014/main" id="{B6164E64-4683-F6B2-A4E8-3147F1ED829E}"/>
-              </a:ext>
-            </a:extLst>
-          </p:cNvPr>
-          <p:cNvSpPr>
-            <a:spLocks noGrp="1"/>
-          </p:cNvSpPr>
-          <p:nvPr>
-            <p:ph type="dt" sz="half" idx="10"/>
-          </p:nvPr>
-        </p:nvSpPr>
-        <p:spPr/>
-        <p:txBody>
-          <a:bodyPr/>
-          <a:lstStyle/>
-          <a:p>
-            <a:fld id="{C6EF02CD-913D-490D-9F2F-9D6BDCD607B3}" type="datetime1">
-              <a:rPr lang="it-IT" smtClean="0"/>
-              <a:t>03/01/2026</a:t>
-            </a:fld>
-            <a:endParaRPr lang="en-US"/>
-          </a:p>
-        </p:txBody>
-      </p:sp>
-      <p:sp>
-        <p:nvSpPr>
-          <p:cNvPr id="6" name="Footer Placeholder 5">
-            <a:extLst>
-              <a:ext uri="{FF2B5EF4-FFF2-40B4-BE49-F238E27FC236}">
-                <a16:creationId xmlns:a16="http://schemas.microsoft.com/office/drawing/2014/main" id="{95A6F43F-BCD3-A849-551B-FD5B61092448}"/>
-              </a:ext>
-            </a:extLst>
-          </p:cNvPr>
-          <p:cNvSpPr>
-            <a:spLocks noGrp="1"/>
-          </p:cNvSpPr>
-          <p:nvPr>
-            <p:ph type="ftr" sz="quarter" idx="11"/>
-          </p:nvPr>
-        </p:nvSpPr>
-        <p:spPr/>
-        <p:txBody>
-          <a:bodyPr/>
-          <a:lstStyle/>
-          <a:p>
-            <a:r>
-              <a:rPr lang="nn-NO"/>
-              <a:t>DINO MENG [SM3201466], BsC AIDA@MIGE</a:t>
-            </a:r>
-            <a:endParaRPr lang="en-US"/>
-          </a:p>
-        </p:txBody>
-      </p:sp>
-      <p:sp>
-        <p:nvSpPr>
-          <p:cNvPr id="7" name="Slide Number Placeholder 6">
-            <a:extLst>
-              <a:ext uri="{FF2B5EF4-FFF2-40B4-BE49-F238E27FC236}">
-                <a16:creationId xmlns:a16="http://schemas.microsoft.com/office/drawing/2014/main" id="{B0F95E78-CE82-F067-7EBD-C1EB7772B1B7}"/>
-              </a:ext>
-            </a:extLst>
-          </p:cNvPr>
-          <p:cNvSpPr>
-            <a:spLocks noGrp="1"/>
-          </p:cNvSpPr>
-          <p:nvPr>
-            <p:ph type="sldNum" sz="quarter" idx="12"/>
-          </p:nvPr>
-        </p:nvSpPr>
-        <p:spPr/>
-        <p:txBody>
-          <a:bodyPr/>
-          <a:lstStyle/>
-          <a:p>
-            <a:fld id="{8BF32AC9-143A-477E-841D-1F801B7F8FE8}" type="slidenum">
-              <a:rPr lang="en-US" smtClean="0"/>
-              <a:t>31</a:t>
-            </a:fld>
-            <a:endParaRPr lang="en-US"/>
-          </a:p>
-        </p:txBody>
-      </p:sp>
-      <p:pic>
-        <p:nvPicPr>
-          <p:cNvPr id="8" name="Picture 7" descr="A graph of different colored lines&#10;&#10;AI-generated content may be incorrect.">
-            <a:extLst>
-              <a:ext uri="{FF2B5EF4-FFF2-40B4-BE49-F238E27FC236}">
-                <a16:creationId xmlns:a16="http://schemas.microsoft.com/office/drawing/2014/main" id="{55C000E7-208C-EC4A-1744-A812B88A24F4}"/>
-              </a:ext>
-            </a:extLst>
-          </p:cNvPr>
-          <p:cNvPicPr>
-            <a:picLocks noChangeAspect="1"/>
-          </p:cNvPicPr>
-          <p:nvPr/>
-        </p:nvPicPr>
-        <p:blipFill>
-          <a:blip r:embed="rId2"/>
-          <a:stretch>
-            <a:fillRect/>
-          </a:stretch>
-        </p:blipFill>
-        <p:spPr>
-          <a:xfrm>
-            <a:off x="1150340" y="1416015"/>
-            <a:ext cx="9891320" cy="4629817"/>
-          </a:xfrm>
-          <a:prstGeom prst="rect">
-            <a:avLst/>
-          </a:prstGeom>
-        </p:spPr>
-      </p:pic>
-    </p:spTree>
-    <p:extLst>
-      <p:ext uri="{BB962C8B-B14F-4D97-AF65-F5344CB8AC3E}">
-        <p14:creationId xmlns:p14="http://schemas.microsoft.com/office/powerpoint/2010/main" val="202612540"/>
       </p:ext>
     </p:extLst>
   </p:cSld>
@@ -13741,7 +13090,7 @@
           <a:p>
             <a:fld id="{D9845C1A-9AE7-4CFB-B4BB-FF54D6A71ADB}" type="datetime1">
               <a:rPr lang="it-IT" smtClean="0"/>
-              <a:t>03/01/2026</a:t>
+              <a:t>04/01/2026</a:t>
             </a:fld>
             <a:endParaRPr lang="en-US"/>
           </a:p>
@@ -14239,7 +13588,7 @@
           <a:p>
             <a:fld id="{5DCCCD83-F29B-4178-A789-3E26EABE1C7A}" type="datetime1">
               <a:rPr lang="it-IT" smtClean="0"/>
-              <a:t>03/01/2026</a:t>
+              <a:t>04/01/2026</a:t>
             </a:fld>
             <a:endParaRPr lang="en-US"/>
           </a:p>
@@ -14615,7 +13964,7 @@
           <a:p>
             <a:fld id="{4C441016-63A1-42AC-B939-9B58CF64338C}" type="datetime1">
               <a:rPr lang="it-IT" smtClean="0"/>
-              <a:t>03/01/2026</a:t>
+              <a:t>04/01/2026</a:t>
             </a:fld>
             <a:endParaRPr lang="en-US"/>
           </a:p>
@@ -15021,7 +14370,7 @@
           <a:p>
             <a:fld id="{63B55B49-8341-42AA-9537-F1E5653FF438}" type="datetime1">
               <a:rPr lang="it-IT" smtClean="0"/>
-              <a:t>03/01/2026</a:t>
+              <a:t>04/01/2026</a:t>
             </a:fld>
             <a:endParaRPr lang="en-US"/>
           </a:p>
@@ -15296,7 +14645,7 @@
           <a:p>
             <a:fld id="{8B082B6C-FF82-4F52-8DBB-5FB157E26F63}" type="datetime1">
               <a:rPr lang="it-IT" smtClean="0"/>
-              <a:t>03/01/2026</a:t>
+              <a:t>04/01/2026</a:t>
             </a:fld>
             <a:endParaRPr lang="en-US"/>
           </a:p>
@@ -15483,8 +14832,8 @@
           </a:p>
         </p:txBody>
       </p:sp>
-      <mc:AlternateContent xmlns:mc="http://schemas.openxmlformats.org/markup-compatibility/2006">
-        <mc:Choice xmlns:a14="http://schemas.microsoft.com/office/drawing/2010/main" Requires="a14">
+      <mc:AlternateContent xmlns:mc="http://schemas.openxmlformats.org/markup-compatibility/2006" xmlns:a14="http://schemas.microsoft.com/office/drawing/2010/main">
+        <mc:Choice Requires="a14">
           <p:sp>
             <p:nvSpPr>
               <p:cNvPr id="7" name="TextBox 6">
@@ -15857,7 +15206,7 @@
             </p:txBody>
           </p:sp>
         </mc:Choice>
-        <mc:Fallback>
+        <mc:Fallback xmlns="">
           <p:sp>
             <p:nvSpPr>
               <p:cNvPr id="7" name="TextBox 6">
@@ -15991,7 +15340,7 @@
           <a:p>
             <a:fld id="{777D5E0C-B568-4CE8-9D10-8B739A803584}" type="datetime1">
               <a:rPr lang="it-IT" smtClean="0"/>
-              <a:t>03/01/2026</a:t>
+              <a:t>04/01/2026</a:t>
             </a:fld>
             <a:endParaRPr lang="en-US"/>
           </a:p>

</xml_diff>

<commit_message>
refusi segnalati da marco carmignano
</commit_message>
<xml_diff>
--- a/Complex Systems/project/PresentationPROJECTSM3201466.pptx
+++ b/Complex Systems/project/PresentationPROJECTSM3201466.pptx
@@ -5273,7 +5273,7 @@
             </a:r>
           </a:p>
           <a:p>
-            <a:pPr marL="285750" indent="-285750">
+            <a:pPr marL="742950" lvl="1" indent="-285750">
               <a:buFont typeface="Wingdings" panose="05000000000000000000" pitchFamily="2" charset="2"/>
               <a:buChar char="q"/>
             </a:pPr>
@@ -5292,18 +5292,21 @@
                 <a:latin typeface="Arial" panose="020B0604020202020204" pitchFamily="34" charset="0"/>
                 <a:cs typeface="Arial" panose="020B0604020202020204" pitchFamily="34" charset="0"/>
               </a:rPr>
-              <a:t>Vediamo una carrellata di risultati + interpretazione biologica</a:t>
-            </a:r>
-          </a:p>
-          <a:p>
-            <a:pPr marL="285750" indent="-285750">
+              <a:t>Vediamo i risultati prodotti</a:t>
+            </a:r>
+          </a:p>
+          <a:p>
+            <a:pPr marL="742950" lvl="1" indent="-285750">
               <a:buFont typeface="Wingdings" panose="05000000000000000000" pitchFamily="2" charset="2"/>
               <a:buChar char="q"/>
             </a:pPr>
-            <a:endParaRPr lang="it-IT" sz="2400" dirty="0">
-              <a:latin typeface="Arial" panose="020B0604020202020204" pitchFamily="34" charset="0"/>
-              <a:cs typeface="Arial" panose="020B0604020202020204" pitchFamily="34" charset="0"/>
-            </a:endParaRPr>
+            <a:r>
+              <a:rPr lang="it-IT" sz="2400" dirty="0">
+                <a:latin typeface="Arial" panose="020B0604020202020204" pitchFamily="34" charset="0"/>
+                <a:cs typeface="Arial" panose="020B0604020202020204" pitchFamily="34" charset="0"/>
+              </a:rPr>
+              <a:t>+ Una loro interpretazione biologica, dove opportuna</a:t>
+            </a:r>
           </a:p>
           <a:p>
             <a:pPr marL="285750" indent="-285750">
@@ -5621,7 +5624,14 @@
                         <a:latin typeface="Cambria Math" panose="02040503050406030204" pitchFamily="18" charset="0"/>
                         <a:cs typeface="Arial" panose="020B0604020202020204" pitchFamily="34" charset="0"/>
                       </a:rPr>
-                      <m:t>=2</m:t>
+                      <m:t>=</m:t>
+                    </m:r>
+                    <m:r>
+                      <a:rPr lang="it-IT" sz="2400" b="0" i="1" smtClean="0">
+                        <a:latin typeface="Cambria Math" panose="02040503050406030204" pitchFamily="18" charset="0"/>
+                        <a:cs typeface="Arial" panose="020B0604020202020204" pitchFamily="34" charset="0"/>
+                      </a:rPr>
+                      <m:t>2</m:t>
                     </m:r>
                   </m:oMath>
                 </a14:m>
@@ -6753,7 +6763,28 @@
                         <a:latin typeface="Cambria Math" panose="02040503050406030204" pitchFamily="18" charset="0"/>
                         <a:cs typeface="Arial" panose="020B0604020202020204" pitchFamily="34" charset="0"/>
                       </a:rPr>
-                      <m:t>=0.002</m:t>
+                      <m:t>=</m:t>
+                    </m:r>
+                    <m:r>
+                      <a:rPr lang="it-IT" sz="2400" i="1">
+                        <a:latin typeface="Cambria Math" panose="02040503050406030204" pitchFamily="18" charset="0"/>
+                        <a:cs typeface="Arial" panose="020B0604020202020204" pitchFamily="34" charset="0"/>
+                      </a:rPr>
+                      <m:t>0</m:t>
+                    </m:r>
+                    <m:r>
+                      <a:rPr lang="it-IT" sz="2400" i="1">
+                        <a:latin typeface="Cambria Math" panose="02040503050406030204" pitchFamily="18" charset="0"/>
+                        <a:cs typeface="Arial" panose="020B0604020202020204" pitchFamily="34" charset="0"/>
+                      </a:rPr>
+                      <m:t>.</m:t>
+                    </m:r>
+                    <m:r>
+                      <a:rPr lang="it-IT" sz="2400" i="1">
+                        <a:latin typeface="Cambria Math" panose="02040503050406030204" pitchFamily="18" charset="0"/>
+                        <a:cs typeface="Arial" panose="020B0604020202020204" pitchFamily="34" charset="0"/>
+                      </a:rPr>
+                      <m:t>002</m:t>
                     </m:r>
                   </m:oMath>
                 </a14:m>
@@ -8248,8 +8279,8 @@
           </a:p>
         </p:txBody>
       </p:sp>
-      <mc:AlternateContent xmlns:mc="http://schemas.openxmlformats.org/markup-compatibility/2006">
-        <mc:Choice xmlns:a14="http://schemas.microsoft.com/office/drawing/2010/main" Requires="a14">
+      <mc:AlternateContent xmlns:mc="http://schemas.openxmlformats.org/markup-compatibility/2006" xmlns:a14="http://schemas.microsoft.com/office/drawing/2010/main">
+        <mc:Choice Requires="a14">
           <p:sp>
             <p:nvSpPr>
               <p:cNvPr id="7" name="TextBox 6">
@@ -8362,7 +8393,7 @@
             </p:txBody>
           </p:sp>
         </mc:Choice>
-        <mc:Fallback>
+        <mc:Fallback xmlns="">
           <p:sp>
             <p:nvSpPr>
               <p:cNvPr id="7" name="TextBox 6">
@@ -9176,8 +9207,8 @@
           </a:p>
         </p:txBody>
       </p:sp>
-      <mc:AlternateContent xmlns:mc="http://schemas.openxmlformats.org/markup-compatibility/2006">
-        <mc:Choice xmlns:a14="http://schemas.microsoft.com/office/drawing/2010/main" Requires="a14">
+      <mc:AlternateContent xmlns:mc="http://schemas.openxmlformats.org/markup-compatibility/2006" xmlns:a14="http://schemas.microsoft.com/office/drawing/2010/main">
+        <mc:Choice Requires="a14">
           <p:sp>
             <p:nvSpPr>
               <p:cNvPr id="7" name="TextBox 6">
@@ -9301,7 +9332,7 @@
             </p:txBody>
           </p:sp>
         </mc:Choice>
-        <mc:Fallback>
+        <mc:Fallback xmlns="">
           <p:sp>
             <p:nvSpPr>
               <p:cNvPr id="7" name="TextBox 6">
@@ -9628,8 +9659,8 @@
           </a:p>
         </p:txBody>
       </p:sp>
-      <mc:AlternateContent xmlns:mc="http://schemas.openxmlformats.org/markup-compatibility/2006">
-        <mc:Choice xmlns:a14="http://schemas.microsoft.com/office/drawing/2010/main" Requires="a14">
+      <mc:AlternateContent xmlns:mc="http://schemas.openxmlformats.org/markup-compatibility/2006" xmlns:a14="http://schemas.microsoft.com/office/drawing/2010/main">
+        <mc:Choice Requires="a14">
           <p:sp>
             <p:nvSpPr>
               <p:cNvPr id="7" name="TextBox 6">
@@ -9714,14 +9745,35 @@
                         <a:latin typeface="Cambria Math" panose="02040503050406030204" pitchFamily="18" charset="0"/>
                         <a:cs typeface="Arial" panose="020B0604020202020204" pitchFamily="34" charset="0"/>
                       </a:rPr>
-                      <m:t>=0.</m:t>
+                      <m:t>=</m:t>
+                    </m:r>
+                    <m:r>
+                      <a:rPr lang="it-IT" sz="2400" i="1">
+                        <a:latin typeface="Cambria Math" panose="02040503050406030204" pitchFamily="18" charset="0"/>
+                        <a:cs typeface="Arial" panose="020B0604020202020204" pitchFamily="34" charset="0"/>
+                      </a:rPr>
+                      <m:t>0</m:t>
+                    </m:r>
+                    <m:r>
+                      <a:rPr lang="it-IT" sz="2400" i="1">
+                        <a:latin typeface="Cambria Math" panose="02040503050406030204" pitchFamily="18" charset="0"/>
+                        <a:cs typeface="Arial" panose="020B0604020202020204" pitchFamily="34" charset="0"/>
+                      </a:rPr>
+                      <m:t>.</m:t>
                     </m:r>
                     <m:r>
                       <a:rPr lang="it-IT" sz="2400" b="0" i="1" smtClean="0">
                         <a:latin typeface="Cambria Math" panose="02040503050406030204" pitchFamily="18" charset="0"/>
                         <a:cs typeface="Arial" panose="020B0604020202020204" pitchFamily="34" charset="0"/>
                       </a:rPr>
-                      <m:t>1 →</m:t>
+                      <m:t>1</m:t>
+                    </m:r>
+                    <m:r>
+                      <a:rPr lang="it-IT" sz="2400" b="0" i="1" smtClean="0">
+                        <a:latin typeface="Cambria Math" panose="02040503050406030204" pitchFamily="18" charset="0"/>
+                        <a:cs typeface="Arial" panose="020B0604020202020204" pitchFamily="34" charset="0"/>
+                      </a:rPr>
+                      <m:t> →</m:t>
                     </m:r>
                     <m:r>
                       <m:rPr>
@@ -9738,7 +9790,28 @@
                         <a:latin typeface="Cambria Math" panose="02040503050406030204" pitchFamily="18" charset="0"/>
                         <a:cs typeface="Arial" panose="020B0604020202020204" pitchFamily="34" charset="0"/>
                       </a:rPr>
-                      <m:t>= 0.001</m:t>
+                      <m:t>= </m:t>
+                    </m:r>
+                    <m:r>
+                      <a:rPr lang="it-IT" sz="2400" b="0" i="1" smtClean="0">
+                        <a:latin typeface="Cambria Math" panose="02040503050406030204" pitchFamily="18" charset="0"/>
+                        <a:cs typeface="Arial" panose="020B0604020202020204" pitchFamily="34" charset="0"/>
+                      </a:rPr>
+                      <m:t>0</m:t>
+                    </m:r>
+                    <m:r>
+                      <a:rPr lang="it-IT" sz="2400" b="0" i="1" smtClean="0">
+                        <a:latin typeface="Cambria Math" panose="02040503050406030204" pitchFamily="18" charset="0"/>
+                        <a:cs typeface="Arial" panose="020B0604020202020204" pitchFamily="34" charset="0"/>
+                      </a:rPr>
+                      <m:t>.</m:t>
+                    </m:r>
+                    <m:r>
+                      <a:rPr lang="it-IT" sz="2400" b="0" i="1" smtClean="0">
+                        <a:latin typeface="Cambria Math" panose="02040503050406030204" pitchFamily="18" charset="0"/>
+                        <a:cs typeface="Arial" panose="020B0604020202020204" pitchFamily="34" charset="0"/>
+                      </a:rPr>
+                      <m:t>001</m:t>
                     </m:r>
                   </m:oMath>
                 </a14:m>
@@ -9766,7 +9839,28 @@
                         <a:latin typeface="Cambria Math" panose="02040503050406030204" pitchFamily="18" charset="0"/>
                         <a:cs typeface="Arial" panose="020B0604020202020204" pitchFamily="34" charset="0"/>
                       </a:rPr>
-                      <m:t>=0.03</m:t>
+                      <m:t>=</m:t>
+                    </m:r>
+                    <m:r>
+                      <a:rPr lang="it-IT" sz="2400" b="0" i="1" smtClean="0">
+                        <a:latin typeface="Cambria Math" panose="02040503050406030204" pitchFamily="18" charset="0"/>
+                        <a:cs typeface="Arial" panose="020B0604020202020204" pitchFamily="34" charset="0"/>
+                      </a:rPr>
+                      <m:t>0</m:t>
+                    </m:r>
+                    <m:r>
+                      <a:rPr lang="it-IT" sz="2400" b="0" i="1" smtClean="0">
+                        <a:latin typeface="Cambria Math" panose="02040503050406030204" pitchFamily="18" charset="0"/>
+                        <a:cs typeface="Arial" panose="020B0604020202020204" pitchFamily="34" charset="0"/>
+                      </a:rPr>
+                      <m:t>.</m:t>
+                    </m:r>
+                    <m:r>
+                      <a:rPr lang="it-IT" sz="2400" b="0" i="1" smtClean="0">
+                        <a:latin typeface="Cambria Math" panose="02040503050406030204" pitchFamily="18" charset="0"/>
+                        <a:cs typeface="Arial" panose="020B0604020202020204" pitchFamily="34" charset="0"/>
+                      </a:rPr>
+                      <m:t>03</m:t>
                     </m:r>
                   </m:oMath>
                 </a14:m>
@@ -9801,7 +9895,7 @@
             </p:txBody>
           </p:sp>
         </mc:Choice>
-        <mc:Fallback>
+        <mc:Fallback xmlns="">
           <p:sp>
             <p:nvSpPr>
               <p:cNvPr id="7" name="TextBox 6">
@@ -11430,8 +11524,8 @@
           </a:p>
         </p:txBody>
       </p:sp>
-      <mc:AlternateContent xmlns:mc="http://schemas.openxmlformats.org/markup-compatibility/2006">
-        <mc:Choice xmlns:a14="http://schemas.microsoft.com/office/drawing/2010/main" Requires="a14">
+      <mc:AlternateContent xmlns:mc="http://schemas.openxmlformats.org/markup-compatibility/2006" xmlns:a14="http://schemas.microsoft.com/office/drawing/2010/main">
+        <mc:Choice Requires="a14">
           <p:sp>
             <p:nvSpPr>
               <p:cNvPr id="11" name="TextBox 10">
@@ -11460,6 +11554,7 @@
               </a:bodyPr>
               <a:lstStyle/>
               <a:p>
+                <a:pPr/>
                 <a14:m>
                   <m:oMathPara xmlns:m="http://schemas.openxmlformats.org/officeDocument/2006/math">
                     <m:oMathParaPr>
@@ -11510,6 +11605,7 @@
                 </a:endParaRPr>
               </a:p>
               <a:p>
+                <a:pPr/>
                 <a14:m>
                   <m:oMathPara xmlns:m="http://schemas.openxmlformats.org/officeDocument/2006/math">
                     <m:oMathParaPr>
@@ -11560,6 +11656,7 @@
                 </a:endParaRPr>
               </a:p>
               <a:p>
+                <a:pPr/>
                 <a14:m>
                   <m:oMathPara xmlns:m="http://schemas.openxmlformats.org/officeDocument/2006/math">
                     <m:oMathParaPr>
@@ -11615,7 +11712,7 @@
             </p:txBody>
           </p:sp>
         </mc:Choice>
-        <mc:Fallback>
+        <mc:Fallback xmlns="">
           <p:sp>
             <p:nvSpPr>
               <p:cNvPr id="11" name="TextBox 10">
@@ -12212,8 +12309,8 @@
           </a:p>
         </p:txBody>
       </p:sp>
-      <mc:AlternateContent xmlns:mc="http://schemas.openxmlformats.org/markup-compatibility/2006">
-        <mc:Choice xmlns:a14="http://schemas.microsoft.com/office/drawing/2010/main" Requires="a14">
+      <mc:AlternateContent xmlns:mc="http://schemas.openxmlformats.org/markup-compatibility/2006" xmlns:a14="http://schemas.microsoft.com/office/drawing/2010/main">
+        <mc:Choice Requires="a14">
           <p:sp>
             <p:nvSpPr>
               <p:cNvPr id="10" name="TextBox 9">
@@ -12242,6 +12339,7 @@
               </a:bodyPr>
               <a:lstStyle/>
               <a:p>
+                <a:pPr/>
                 <a14:m>
                   <m:oMathPara xmlns:m="http://schemas.openxmlformats.org/officeDocument/2006/math">
                     <m:oMathParaPr>
@@ -12295,6 +12393,7 @@
                 </a:endParaRPr>
               </a:p>
               <a:p>
+                <a:pPr/>
                 <a14:m>
                   <m:oMathPara xmlns:m="http://schemas.openxmlformats.org/officeDocument/2006/math">
                     <m:oMathParaPr>
@@ -12348,6 +12447,7 @@
                 </a:endParaRPr>
               </a:p>
               <a:p>
+                <a:pPr/>
                 <a14:m>
                   <m:oMathPara xmlns:m="http://schemas.openxmlformats.org/officeDocument/2006/math">
                     <m:oMathParaPr>
@@ -12403,7 +12503,7 @@
             </p:txBody>
           </p:sp>
         </mc:Choice>
-        <mc:Fallback>
+        <mc:Fallback xmlns="">
           <p:sp>
             <p:nvSpPr>
               <p:cNvPr id="10" name="TextBox 9">
@@ -15069,8 +15169,8 @@
           </a:p>
         </p:txBody>
       </p:sp>
-      <mc:AlternateContent xmlns:mc="http://schemas.openxmlformats.org/markup-compatibility/2006" xmlns:a14="http://schemas.microsoft.com/office/drawing/2010/main">
-        <mc:Choice Requires="a14">
+      <mc:AlternateContent xmlns:mc="http://schemas.openxmlformats.org/markup-compatibility/2006">
+        <mc:Choice xmlns:a14="http://schemas.microsoft.com/office/drawing/2010/main" Requires="a14">
           <p:sp>
             <p:nvSpPr>
               <p:cNvPr id="2" name="TextBox 1">
@@ -15201,7 +15301,21 @@
                         <a:latin typeface="Cambria Math" panose="02040503050406030204" pitchFamily="18" charset="0"/>
                         <a:cs typeface="Arial" panose="020B0604020202020204" pitchFamily="34" charset="0"/>
                       </a:rPr>
-                      <m:t>=0, </m:t>
+                      <m:t>=</m:t>
+                    </m:r>
+                    <m:r>
+                      <a:rPr lang="it-IT" sz="2400" b="0" i="1" smtClean="0">
+                        <a:latin typeface="Cambria Math" panose="02040503050406030204" pitchFamily="18" charset="0"/>
+                        <a:cs typeface="Arial" panose="020B0604020202020204" pitchFamily="34" charset="0"/>
+                      </a:rPr>
+                      <m:t>0</m:t>
+                    </m:r>
+                    <m:r>
+                      <a:rPr lang="it-IT" sz="2400" b="0" i="1" smtClean="0">
+                        <a:latin typeface="Cambria Math" panose="02040503050406030204" pitchFamily="18" charset="0"/>
+                        <a:cs typeface="Arial" panose="020B0604020202020204" pitchFamily="34" charset="0"/>
+                      </a:rPr>
+                      <m:t>, </m:t>
                     </m:r>
                     <m:r>
                       <m:rPr>
@@ -15218,7 +15332,14 @@
                         <a:latin typeface="Cambria Math" panose="02040503050406030204" pitchFamily="18" charset="0"/>
                         <a:cs typeface="Arial" panose="020B0604020202020204" pitchFamily="34" charset="0"/>
                       </a:rPr>
-                      <m:t>=1</m:t>
+                      <m:t>=</m:t>
+                    </m:r>
+                    <m:r>
+                      <a:rPr lang="it-IT" sz="2400" b="0" i="1" smtClean="0">
+                        <a:latin typeface="Cambria Math" panose="02040503050406030204" pitchFamily="18" charset="0"/>
+                        <a:cs typeface="Arial" panose="020B0604020202020204" pitchFamily="34" charset="0"/>
+                      </a:rPr>
+                      <m:t>1</m:t>
                     </m:r>
                   </m:oMath>
                 </a14:m>
@@ -15292,7 +15413,14 @@
                         <a:latin typeface="Cambria Math" panose="02040503050406030204" pitchFamily="18" charset="0"/>
                         <a:cs typeface="Arial" panose="020B0604020202020204" pitchFamily="34" charset="0"/>
                       </a:rPr>
-                      <m:t>=1</m:t>
+                      <m:t>=</m:t>
+                    </m:r>
+                    <m:r>
+                      <a:rPr lang="it-IT" sz="2400" b="0" i="1" smtClean="0">
+                        <a:latin typeface="Cambria Math" panose="02040503050406030204" pitchFamily="18" charset="0"/>
+                        <a:cs typeface="Arial" panose="020B0604020202020204" pitchFamily="34" charset="0"/>
+                      </a:rPr>
+                      <m:t>1</m:t>
                     </m:r>
                     <m:r>
                       <a:rPr lang="it-IT" sz="2400" b="0" i="0" smtClean="0">
@@ -15398,7 +15526,21 @@
                         <a:latin typeface="Cambria Math" panose="02040503050406030204" pitchFamily="18" charset="0"/>
                         <a:cs typeface="Arial" panose="020B0604020202020204" pitchFamily="34" charset="0"/>
                       </a:rPr>
-                      <m:t>=1−</m:t>
+                      <m:t>=</m:t>
+                    </m:r>
+                    <m:r>
+                      <a:rPr lang="it-IT" sz="2400" b="0" i="1" smtClean="0">
+                        <a:latin typeface="Cambria Math" panose="02040503050406030204" pitchFamily="18" charset="0"/>
+                        <a:cs typeface="Arial" panose="020B0604020202020204" pitchFamily="34" charset="0"/>
+                      </a:rPr>
+                      <m:t>1</m:t>
+                    </m:r>
+                    <m:r>
+                      <a:rPr lang="it-IT" sz="2400" b="0" i="1" smtClean="0">
+                        <a:latin typeface="Cambria Math" panose="02040503050406030204" pitchFamily="18" charset="0"/>
+                        <a:cs typeface="Arial" panose="020B0604020202020204" pitchFamily="34" charset="0"/>
+                      </a:rPr>
+                      <m:t>−</m:t>
                     </m:r>
                     <m:r>
                       <a:rPr lang="it-IT" sz="2400" b="0" i="1" smtClean="0">
@@ -15416,6 +15558,9 @@
                     </m:r>
                     <m:r>
                       <a:rPr lang="it-IT" sz="2400" b="0" i="1" smtClean="0">
+                        <a:highlight>
+                          <a:srgbClr val="FFFF00"/>
+                        </a:highlight>
                         <a:latin typeface="Cambria Math" panose="02040503050406030204" pitchFamily="18" charset="0"/>
                         <a:cs typeface="Arial" panose="020B0604020202020204" pitchFamily="34" charset="0"/>
                       </a:rPr>
@@ -15423,6 +15568,9 @@
                     </m:r>
                     <m:r>
                       <a:rPr lang="it-IT" sz="2400" b="0" i="1" smtClean="0">
+                        <a:highlight>
+                          <a:srgbClr val="FFFF00"/>
+                        </a:highlight>
                         <a:latin typeface="Cambria Math" panose="02040503050406030204" pitchFamily="18" charset="0"/>
                         <a:cs typeface="Arial" panose="020B0604020202020204" pitchFamily="34" charset="0"/>
                       </a:rPr>
@@ -15430,6 +15578,9 @@
                     </m:r>
                     <m:r>
                       <a:rPr lang="it-IT" sz="2400" b="0" i="1" smtClean="0">
+                        <a:highlight>
+                          <a:srgbClr val="FFFF00"/>
+                        </a:highlight>
                         <a:latin typeface="Cambria Math" panose="02040503050406030204" pitchFamily="18" charset="0"/>
                         <a:cs typeface="Arial" panose="020B0604020202020204" pitchFamily="34" charset="0"/>
                       </a:rPr>
@@ -15437,6 +15588,9 @@
                     </m:r>
                     <m:r>
                       <a:rPr lang="it-IT" sz="2400" b="0" i="1" smtClean="0">
+                        <a:highlight>
+                          <a:srgbClr val="FFFF00"/>
+                        </a:highlight>
                         <a:latin typeface="Cambria Math" panose="02040503050406030204" pitchFamily="18" charset="0"/>
                         <a:cs typeface="Arial" panose="020B0604020202020204" pitchFamily="34" charset="0"/>
                       </a:rPr>
@@ -15464,7 +15618,21 @@
                         <a:latin typeface="Cambria Math" panose="02040503050406030204" pitchFamily="18" charset="0"/>
                         <a:cs typeface="Arial" panose="020B0604020202020204" pitchFamily="34" charset="0"/>
                       </a:rPr>
-                      <m:t>=1/</m:t>
+                      <m:t>=</m:t>
+                    </m:r>
+                    <m:r>
+                      <a:rPr lang="it-IT" sz="2400" b="0" i="1" smtClean="0">
+                        <a:latin typeface="Cambria Math" panose="02040503050406030204" pitchFamily="18" charset="0"/>
+                        <a:cs typeface="Arial" panose="020B0604020202020204" pitchFamily="34" charset="0"/>
+                      </a:rPr>
+                      <m:t>1</m:t>
+                    </m:r>
+                    <m:r>
+                      <a:rPr lang="it-IT" sz="2400" b="0" i="1" smtClean="0">
+                        <a:latin typeface="Cambria Math" panose="02040503050406030204" pitchFamily="18" charset="0"/>
+                        <a:cs typeface="Arial" panose="020B0604020202020204" pitchFamily="34" charset="0"/>
+                      </a:rPr>
+                      <m:t>/</m:t>
                     </m:r>
                     <m:r>
                       <m:rPr>
@@ -15509,7 +15677,7 @@
             </p:txBody>
           </p:sp>
         </mc:Choice>
-        <mc:Fallback xmlns="">
+        <mc:Fallback>
           <p:sp>
             <p:nvSpPr>
               <p:cNvPr id="2" name="TextBox 1">
@@ -17524,8 +17692,8 @@
           </a:p>
         </p:txBody>
       </p:sp>
-      <mc:AlternateContent xmlns:mc="http://schemas.openxmlformats.org/markup-compatibility/2006" xmlns:a14="http://schemas.microsoft.com/office/drawing/2010/main">
-        <mc:Choice Requires="a14">
+      <mc:AlternateContent xmlns:mc="http://schemas.openxmlformats.org/markup-compatibility/2006">
+        <mc:Choice xmlns:a14="http://schemas.microsoft.com/office/drawing/2010/main" Requires="a14">
           <p:sp>
             <p:nvSpPr>
               <p:cNvPr id="2" name="TextBox 1">
@@ -17595,7 +17763,7 @@
                   <a:buChar char="q"/>
                 </a:pPr>
                 <a:r>
-                  <a:rPr lang="it-IT" sz="2400" i="1" dirty="0">
+                  <a:rPr lang="it-IT" sz="2400" b="1" i="1" dirty="0">
                     <a:latin typeface="Arial" panose="020B0604020202020204" pitchFamily="34" charset="0"/>
                     <a:cs typeface="Arial" panose="020B0604020202020204" pitchFamily="34" charset="0"/>
                   </a:rPr>
@@ -17666,7 +17834,7 @@
                   <a:buChar char="q"/>
                 </a:pPr>
                 <a:r>
-                  <a:rPr lang="it-IT" sz="2400" dirty="0">
+                  <a:rPr lang="it-IT" sz="2400" b="1" i="1" dirty="0">
                     <a:latin typeface="Arial" panose="020B0604020202020204" pitchFamily="34" charset="0"/>
                     <a:cs typeface="Arial" panose="020B0604020202020204" pitchFamily="34" charset="0"/>
                   </a:rPr>
@@ -17844,7 +18012,7 @@
                     <a:latin typeface="Arial" panose="020B0604020202020204" pitchFamily="34" charset="0"/>
                     <a:cs typeface="Arial" panose="020B0604020202020204" pitchFamily="34" charset="0"/>
                   </a:rPr>
-                  <a:t>Effettuiamo un po’ di esperimenti al variare dei parametri</a:t>
+                  <a:t>Effettuiamo un po’ di esperimenti con questa famiglia di oscillatori</a:t>
                 </a:r>
               </a:p>
               <a:p>
@@ -17873,7 +18041,7 @@
                   <a:buChar char="q"/>
                 </a:pPr>
                 <a:r>
-                  <a:rPr lang="it-IT" sz="2400" dirty="0">
+                  <a:rPr lang="it-IT" sz="2400" b="1" i="1" dirty="0">
                     <a:latin typeface="Arial" panose="020B0604020202020204" pitchFamily="34" charset="0"/>
                     <a:cs typeface="Arial" panose="020B0604020202020204" pitchFamily="34" charset="0"/>
                   </a:rPr>
@@ -17906,7 +18074,7 @@
             </p:txBody>
           </p:sp>
         </mc:Choice>
-        <mc:Fallback xmlns="">
+        <mc:Fallback>
           <p:sp>
             <p:nvSpPr>
               <p:cNvPr id="2" name="TextBox 1">
@@ -19085,8 +19253,8 @@
           </a:p>
         </p:txBody>
       </p:sp>
-      <mc:AlternateContent xmlns:mc="http://schemas.openxmlformats.org/markup-compatibility/2006">
-        <mc:Choice xmlns:a14="http://schemas.microsoft.com/office/drawing/2010/main" Requires="a14">
+      <mc:AlternateContent xmlns:mc="http://schemas.openxmlformats.org/markup-compatibility/2006" xmlns:a14="http://schemas.microsoft.com/office/drawing/2010/main">
+        <mc:Choice Requires="a14">
           <p:sp>
             <p:nvSpPr>
               <p:cNvPr id="8" name="TextBox 7">
@@ -19195,7 +19363,7 @@
             </p:txBody>
           </p:sp>
         </mc:Choice>
-        <mc:Fallback>
+        <mc:Fallback xmlns="">
           <p:sp>
             <p:nvSpPr>
               <p:cNvPr id="8" name="TextBox 7">
@@ -23839,8 +24007,8 @@
           </a:p>
         </p:txBody>
       </p:sp>
-      <mc:AlternateContent xmlns:mc="http://schemas.openxmlformats.org/markup-compatibility/2006">
-        <mc:Choice xmlns:a14="http://schemas.microsoft.com/office/drawing/2010/main" Requires="a14">
+      <mc:AlternateContent xmlns:mc="http://schemas.openxmlformats.org/markup-compatibility/2006" xmlns:a14="http://schemas.microsoft.com/office/drawing/2010/main">
+        <mc:Choice Requires="a14">
           <p:sp>
             <p:nvSpPr>
               <p:cNvPr id="7" name="TextBox 6">
@@ -24570,7 +24738,7 @@
             </p:txBody>
           </p:sp>
         </mc:Choice>
-        <mc:Fallback>
+        <mc:Fallback xmlns="">
           <p:sp>
             <p:nvSpPr>
               <p:cNvPr id="7" name="TextBox 6">

</xml_diff>